<commit_message>
Pitch CGI : repositionnement client-first (rachat en option)
Le deck et la fiche de prep visent désormais en priorité CGI comme CLIENT
(adoption + déploiement en abonnement sur ses entités). Partenariat et
acquisition deviennent des options ultérieures (slide « Et après »). Narratif,
ROI, posture, Q&A et demande ajustés en conséquence.
</commit_message>
<xml_diff>
--- a/deliverables/Konsilys_Pitch_CGI.pptx
+++ b/deliverables/Konsilys_Pitch_CGI.pptx
@@ -3413,7 +3413,7 @@
         <p:spPr>
           <a:xfrm>
             <a:off x="914400" y="1828800"/>
-            <a:ext cx="5486400" cy="384048"/>
+            <a:ext cx="5760720" cy="384048"/>
           </a:xfrm>
           <a:prstGeom prst="roundRect">
             <a:avLst/>
@@ -3456,7 +3456,7 @@
                 </a:solidFill>
                 <a:latin typeface="Calibri"/>
               </a:rPr>
-              <a:t>Proposition de partenariat stratégique · Confidentiel</a:t>
+              <a:t>Solution de pilotage pour les entités CGI · Confidentiel</a:t>
             </a:r>
           </a:p>
         </p:txBody>
@@ -3495,7 +3495,7 @@
                 </a:solidFill>
                 <a:latin typeface="Calibri"/>
               </a:rPr>
-              <a:t>Konsilys × CGI</a:t>
+              <a:t>Konsilys pour CGI</a:t>
             </a:r>
           </a:p>
           <a:p>
@@ -3511,7 +3511,7 @@
                 </a:solidFill>
                 <a:latin typeface="Calibri"/>
               </a:rPr>
-              <a:t>Une plateforme SaaS de pilotage des sociétés de conseil, déjà en production — et une opportunité pour CGI : agilité interne et actif produit différenciant.</a:t>
+              <a:t>Une plateforme SaaS de pilotage des activités de conseil, déjà en production — prête à déployer sur vos entités pour un pilotage opérationnel en temps réel.</a:t>
             </a:r>
           </a:p>
         </p:txBody>
@@ -3626,7 +3626,7 @@
         <p:spPr>
           <a:xfrm>
             <a:off x="822960" y="566928"/>
-            <a:ext cx="1847088" cy="384048"/>
+            <a:ext cx="3163824" cy="384048"/>
           </a:xfrm>
           <a:prstGeom prst="roundRect">
             <a:avLst/>
@@ -3669,7 +3669,7 @@
                 </a:solidFill>
                 <a:latin typeface="Calibri"/>
               </a:rPr>
-              <a:t>Options</a:t>
+              <a:t>Comment démarrer</a:t>
             </a:r>
           </a:p>
         </p:txBody>
@@ -3708,21 +3708,78 @@
                 </a:solidFill>
                 <a:latin typeface="Calibri"/>
               </a:rPr>
-              <a:t>Un spectre, du pilote à l'acquisition</a:t>
-            </a:r>
-          </a:p>
-        </p:txBody>
-      </p:sp>
-      <p:sp>
-        <p:nvSpPr>
-          <p:cNvPr id="5" name="Rounded Rectangle 4"/>
+              <a:t>Un parcours simple, sans risque</a:t>
+            </a:r>
+          </a:p>
+        </p:txBody>
+      </p:sp>
+      <p:sp>
+        <p:nvSpPr>
+          <p:cNvPr id="5" name="Oval 4"/>
           <p:cNvSpPr/>
           <p:nvPr/>
         </p:nvSpPr>
         <p:spPr>
           <a:xfrm>
-            <a:off x="822960" y="1965960"/>
-            <a:ext cx="3502152" cy="2651760"/>
+            <a:off x="868680" y="2103120"/>
+            <a:ext cx="502920" cy="502920"/>
+          </a:xfrm>
+          <a:prstGeom prst="ellipse">
+            <a:avLst/>
+          </a:prstGeom>
+          <a:solidFill>
+            <a:srgbClr val="84CC16"/>
+          </a:solidFill>
+          <a:ln>
+            <a:noFill/>
+          </a:ln>
+          <a:effectLst/>
+        </p:spPr>
+        <p:style>
+          <a:lnRef idx="1">
+            <a:schemeClr val="accent1"/>
+          </a:lnRef>
+          <a:fillRef idx="3">
+            <a:schemeClr val="accent1"/>
+          </a:fillRef>
+          <a:effectRef idx="2">
+            <a:schemeClr val="accent1"/>
+          </a:effectRef>
+          <a:fontRef idx="minor">
+            <a:schemeClr val="lt1"/>
+          </a:fontRef>
+        </p:style>
+        <p:txBody>
+          <a:bodyPr rtlCol="0" anchor="ctr"/>
+          <a:lstStyle/>
+          <a:p>
+            <a:pPr algn="ctr">
+              <a:spcAft>
+                <a:spcPts val="500"/>
+              </a:spcAft>
+            </a:pPr>
+            <a:r>
+              <a:rPr sz="1800" b="1" i="0">
+                <a:solidFill>
+                  <a:srgbClr val="1B2B3A"/>
+                </a:solidFill>
+                <a:latin typeface="Calibri"/>
+              </a:rPr>
+              <a:t>1</a:t>
+            </a:r>
+          </a:p>
+        </p:txBody>
+      </p:sp>
+      <p:sp>
+        <p:nvSpPr>
+          <p:cNvPr id="6" name="Rounded Rectangle 5"/>
+          <p:cNvSpPr/>
+          <p:nvPr/>
+        </p:nvSpPr>
+        <p:spPr>
+          <a:xfrm>
+            <a:off x="1600200" y="2011679"/>
+            <a:ext cx="9765792" cy="960120"/>
           </a:xfrm>
           <a:prstGeom prst="roundRect">
             <a:avLst/>
@@ -3761,20 +3818,75 @@
       </p:sp>
       <p:sp>
         <p:nvSpPr>
-          <p:cNvPr id="6" name="Rounded Rectangle 5"/>
+          <p:cNvPr id="7" name="TextBox 6"/>
+          <p:cNvSpPr txBox="1"/>
+          <p:nvPr/>
+        </p:nvSpPr>
+        <p:spPr>
+          <a:xfrm>
+            <a:off x="1874519" y="2148839"/>
+            <a:ext cx="9235440" cy="822960"/>
+          </a:xfrm>
+          <a:prstGeom prst="rect">
+            <a:avLst/>
+          </a:prstGeom>
+          <a:noFill/>
+        </p:spPr>
+        <p:txBody>
+          <a:bodyPr wrap="square">
+            <a:spAutoFit/>
+          </a:bodyPr>
+          <a:lstStyle/>
+          <a:p>
+            <a:pPr algn="l">
+              <a:spcAft>
+                <a:spcPts val="200"/>
+              </a:spcAft>
+            </a:pPr>
+            <a:r>
+              <a:rPr sz="1600" b="1" i="0">
+                <a:solidFill>
+                  <a:srgbClr val="1B2B3A"/>
+                </a:solidFill>
+                <a:latin typeface="Calibri"/>
+              </a:rPr>
+              <a:t>Pilote sur une entité</a:t>
+            </a:r>
+          </a:p>
+          <a:p>
+            <a:pPr algn="l">
+              <a:spcAft>
+                <a:spcPts val="500"/>
+              </a:spcAft>
+            </a:pPr>
+            <a:r>
+              <a:rPr sz="1250" b="0" i="0">
+                <a:solidFill>
+                  <a:srgbClr val="647485"/>
+                </a:solidFill>
+                <a:latin typeface="Calibri"/>
+              </a:rPr>
+              <a:t>Une filiale ou BU volontaire, cadré (objectifs, durée, indicateurs). Mise en route en quelques jours.</a:t>
+            </a:r>
+          </a:p>
+        </p:txBody>
+      </p:sp>
+      <p:sp>
+        <p:nvSpPr>
+          <p:cNvPr id="8" name="Oval 7"/>
           <p:cNvSpPr/>
           <p:nvPr/>
         </p:nvSpPr>
         <p:spPr>
           <a:xfrm>
-            <a:off x="1097280" y="2240279"/>
-            <a:ext cx="2103120" cy="384048"/>
-          </a:xfrm>
-          <a:prstGeom prst="roundRect">
-            <a:avLst/>
-          </a:prstGeom>
-          <a:solidFill>
-            <a:srgbClr val="1B2B3A"/>
+            <a:off x="868680" y="3291839"/>
+            <a:ext cx="502920" cy="502920"/>
+          </a:xfrm>
+          <a:prstGeom prst="ellipse">
+            <a:avLst/>
+          </a:prstGeom>
+          <a:solidFill>
+            <a:srgbClr val="84CC16"/>
           </a:solidFill>
           <a:ln>
             <a:noFill/>
@@ -3796,7 +3908,7 @@
           </a:fontRef>
         </p:style>
         <p:txBody>
-          <a:bodyPr rtlCol="0" anchor="ctr" wrap="square"/>
+          <a:bodyPr rtlCol="0" anchor="ctr"/>
           <a:lstStyle/>
           <a:p>
             <a:pPr algn="ctr">
@@ -3805,82 +3917,27 @@
               </a:spcAft>
             </a:pPr>
             <a:r>
-              <a:rPr sz="1100" b="1" i="0">
-                <a:solidFill>
-                  <a:srgbClr val="FFFFFF"/>
-                </a:solidFill>
-                <a:latin typeface="Calibri"/>
-              </a:rPr>
-              <a:t>DÉRISQUER</a:t>
-            </a:r>
-          </a:p>
-        </p:txBody>
-      </p:sp>
-      <p:sp>
-        <p:nvSpPr>
-          <p:cNvPr id="7" name="TextBox 6"/>
-          <p:cNvSpPr txBox="1"/>
-          <p:nvPr/>
-        </p:nvSpPr>
-        <p:spPr>
-          <a:xfrm>
-            <a:off x="1097280" y="2834639"/>
-            <a:ext cx="2953512" cy="1645920"/>
-          </a:xfrm>
-          <a:prstGeom prst="rect">
-            <a:avLst/>
-          </a:prstGeom>
-          <a:noFill/>
-        </p:spPr>
-        <p:txBody>
-          <a:bodyPr wrap="square">
-            <a:spAutoFit/>
-          </a:bodyPr>
-          <a:lstStyle/>
-          <a:p>
-            <a:pPr algn="l">
-              <a:spcAft>
-                <a:spcPts val="600"/>
-              </a:spcAft>
-            </a:pPr>
-            <a:r>
               <a:rPr sz="1800" b="1" i="0">
                 <a:solidFill>
                   <a:srgbClr val="1B2B3A"/>
                 </a:solidFill>
                 <a:latin typeface="Calibri"/>
               </a:rPr>
-              <a:t>Pilote</a:t>
-            </a:r>
-          </a:p>
-          <a:p>
-            <a:pPr algn="l">
-              <a:spcAft>
-                <a:spcPts val="500"/>
-              </a:spcAft>
-            </a:pPr>
-            <a:r>
-              <a:rPr sz="1300" b="0" i="0">
-                <a:solidFill>
-                  <a:srgbClr val="647485"/>
-                </a:solidFill>
-                <a:latin typeface="Calibri"/>
-              </a:rPr>
-              <a:t>Déploiement sur une entité/BU volontaire. Preuve de valeur mesurée avant tout engagement.</a:t>
-            </a:r>
-          </a:p>
-        </p:txBody>
-      </p:sp>
-      <p:sp>
-        <p:nvSpPr>
-          <p:cNvPr id="8" name="Rounded Rectangle 7"/>
+              <a:t>2</a:t>
+            </a:r>
+          </a:p>
+        </p:txBody>
+      </p:sp>
+      <p:sp>
+        <p:nvSpPr>
+          <p:cNvPr id="9" name="Rounded Rectangle 8"/>
           <p:cNvSpPr/>
           <p:nvPr/>
         </p:nvSpPr>
         <p:spPr>
           <a:xfrm>
-            <a:off x="4599432" y="1965960"/>
-            <a:ext cx="3502152" cy="2651760"/>
+            <a:off x="1600200" y="3200399"/>
+            <a:ext cx="9765792" cy="960120"/>
           </a:xfrm>
           <a:prstGeom prst="roundRect">
             <a:avLst/>
@@ -3919,20 +3976,75 @@
       </p:sp>
       <p:sp>
         <p:nvSpPr>
-          <p:cNvPr id="9" name="Rounded Rectangle 8"/>
+          <p:cNvPr id="10" name="TextBox 9"/>
+          <p:cNvSpPr txBox="1"/>
+          <p:nvPr/>
+        </p:nvSpPr>
+        <p:spPr>
+          <a:xfrm>
+            <a:off x="1874519" y="3337559"/>
+            <a:ext cx="9235440" cy="822960"/>
+          </a:xfrm>
+          <a:prstGeom prst="rect">
+            <a:avLst/>
+          </a:prstGeom>
+          <a:noFill/>
+        </p:spPr>
+        <p:txBody>
+          <a:bodyPr wrap="square">
+            <a:spAutoFit/>
+          </a:bodyPr>
+          <a:lstStyle/>
+          <a:p>
+            <a:pPr algn="l">
+              <a:spcAft>
+                <a:spcPts val="200"/>
+              </a:spcAft>
+            </a:pPr>
+            <a:r>
+              <a:rPr sz="1600" b="1" i="0">
+                <a:solidFill>
+                  <a:srgbClr val="1B2B3A"/>
+                </a:solidFill>
+                <a:latin typeface="Calibri"/>
+              </a:rPr>
+              <a:t>Mesure de la valeur</a:t>
+            </a:r>
+          </a:p>
+          <a:p>
+            <a:pPr algn="l">
+              <a:spcAft>
+                <a:spcPts val="500"/>
+              </a:spcAft>
+            </a:pPr>
+            <a:r>
+              <a:rPr sz="1250" b="0" i="0">
+                <a:solidFill>
+                  <a:srgbClr val="647485"/>
+                </a:solidFill>
+                <a:latin typeface="Calibri"/>
+              </a:rPr>
+              <a:t>On compare avant/après : visibilité, temps managérial, qualité du staffing et de la marge.</a:t>
+            </a:r>
+          </a:p>
+        </p:txBody>
+      </p:sp>
+      <p:sp>
+        <p:nvSpPr>
+          <p:cNvPr id="11" name="Oval 10"/>
           <p:cNvSpPr/>
           <p:nvPr/>
         </p:nvSpPr>
         <p:spPr>
           <a:xfrm>
-            <a:off x="4873752" y="2240279"/>
-            <a:ext cx="2103120" cy="384048"/>
-          </a:xfrm>
-          <a:prstGeom prst="roundRect">
-            <a:avLst/>
-          </a:prstGeom>
-          <a:solidFill>
-            <a:srgbClr val="1B2B3A"/>
+            <a:off x="868680" y="4480559"/>
+            <a:ext cx="502920" cy="502920"/>
+          </a:xfrm>
+          <a:prstGeom prst="ellipse">
+            <a:avLst/>
+          </a:prstGeom>
+          <a:solidFill>
+            <a:srgbClr val="84CC16"/>
           </a:solidFill>
           <a:ln>
             <a:noFill/>
@@ -3954,7 +4066,7 @@
           </a:fontRef>
         </p:style>
         <p:txBody>
-          <a:bodyPr rtlCol="0" anchor="ctr" wrap="square"/>
+          <a:bodyPr rtlCol="0" anchor="ctr"/>
           <a:lstStyle/>
           <a:p>
             <a:pPr algn="ctr">
@@ -3963,91 +4075,38 @@
               </a:spcAft>
             </a:pPr>
             <a:r>
-              <a:rPr sz="1100" b="1" i="0">
-                <a:solidFill>
-                  <a:srgbClr val="FFFFFF"/>
-                </a:solidFill>
-                <a:latin typeface="Calibri"/>
-              </a:rPr>
-              <a:t>COLLABORER</a:t>
-            </a:r>
-          </a:p>
-        </p:txBody>
-      </p:sp>
-      <p:sp>
-        <p:nvSpPr>
-          <p:cNvPr id="10" name="TextBox 9"/>
-          <p:cNvSpPr txBox="1"/>
-          <p:nvPr/>
-        </p:nvSpPr>
-        <p:spPr>
-          <a:xfrm>
-            <a:off x="4873752" y="2834639"/>
-            <a:ext cx="2953512" cy="1645920"/>
-          </a:xfrm>
-          <a:prstGeom prst="rect">
-            <a:avLst/>
-          </a:prstGeom>
-          <a:noFill/>
-        </p:spPr>
-        <p:txBody>
-          <a:bodyPr wrap="square">
-            <a:spAutoFit/>
-          </a:bodyPr>
-          <a:lstStyle/>
-          <a:p>
-            <a:pPr algn="l">
-              <a:spcAft>
-                <a:spcPts val="600"/>
-              </a:spcAft>
-            </a:pPr>
-            <a:r>
               <a:rPr sz="1800" b="1" i="0">
                 <a:solidFill>
                   <a:srgbClr val="1B2B3A"/>
                 </a:solidFill>
                 <a:latin typeface="Calibri"/>
               </a:rPr>
-              <a:t>Partenariat / distribution</a:t>
-            </a:r>
-          </a:p>
-          <a:p>
-            <a:pPr algn="l">
-              <a:spcAft>
-                <a:spcPts val="500"/>
-              </a:spcAft>
-            </a:pPr>
-            <a:r>
-              <a:rPr sz="1300" b="0" i="0">
-                <a:solidFill>
-                  <a:srgbClr val="647485"/>
-                </a:solidFill>
-                <a:latin typeface="Calibri"/>
-              </a:rPr>
-              <a:t>CGI distribue ou intègre Konsilys (marque blanche possible), partage de revenus.</a:t>
-            </a:r>
-          </a:p>
-        </p:txBody>
-      </p:sp>
-      <p:sp>
-        <p:nvSpPr>
-          <p:cNvPr id="11" name="Rounded Rectangle 10"/>
+              <a:t>3</a:t>
+            </a:r>
+          </a:p>
+        </p:txBody>
+      </p:sp>
+      <p:sp>
+        <p:nvSpPr>
+          <p:cNvPr id="12" name="Rounded Rectangle 11"/>
           <p:cNvSpPr/>
           <p:nvPr/>
         </p:nvSpPr>
         <p:spPr>
           <a:xfrm>
-            <a:off x="8375904" y="1965960"/>
-            <a:ext cx="3502152" cy="2651760"/>
+            <a:off x="1600200" y="4389120"/>
+            <a:ext cx="9765792" cy="960120"/>
           </a:xfrm>
           <a:prstGeom prst="roundRect">
             <a:avLst/>
           </a:prstGeom>
           <a:solidFill>
-            <a:srgbClr val="0F1720"/>
-          </a:solidFill>
-          <a:ln>
-            <a:noFill/>
+            <a:srgbClr val="F7F9FB"/>
+          </a:solidFill>
+          <a:ln w="12700">
+            <a:solidFill>
+              <a:srgbClr val="E2E8F0"/>
+            </a:solidFill>
           </a:ln>
           <a:effectLst/>
         </p:spPr>
@@ -4075,71 +4134,14 @@
       </p:sp>
       <p:sp>
         <p:nvSpPr>
-          <p:cNvPr id="12" name="Rounded Rectangle 11"/>
-          <p:cNvSpPr/>
-          <p:nvPr/>
-        </p:nvSpPr>
-        <p:spPr>
-          <a:xfrm>
-            <a:off x="8650224" y="2240279"/>
-            <a:ext cx="2103120" cy="384048"/>
-          </a:xfrm>
-          <a:prstGeom prst="roundRect">
-            <a:avLst/>
-          </a:prstGeom>
-          <a:solidFill>
-            <a:srgbClr val="84CC16"/>
-          </a:solidFill>
-          <a:ln>
-            <a:noFill/>
-          </a:ln>
-          <a:effectLst/>
-        </p:spPr>
-        <p:style>
-          <a:lnRef idx="1">
-            <a:schemeClr val="accent1"/>
-          </a:lnRef>
-          <a:fillRef idx="3">
-            <a:schemeClr val="accent1"/>
-          </a:fillRef>
-          <a:effectRef idx="2">
-            <a:schemeClr val="accent1"/>
-          </a:effectRef>
-          <a:fontRef idx="minor">
-            <a:schemeClr val="lt1"/>
-          </a:fontRef>
-        </p:style>
-        <p:txBody>
-          <a:bodyPr rtlCol="0" anchor="ctr" wrap="square"/>
-          <a:lstStyle/>
-          <a:p>
-            <a:pPr algn="ctr">
-              <a:spcAft>
-                <a:spcPts val="500"/>
-              </a:spcAft>
-            </a:pPr>
-            <a:r>
-              <a:rPr sz="1100" b="1" i="0">
-                <a:solidFill>
-                  <a:srgbClr val="1B2B3A"/>
-                </a:solidFill>
-                <a:latin typeface="Calibri"/>
-              </a:rPr>
-              <a:t>INTÉGRER</a:t>
-            </a:r>
-          </a:p>
-        </p:txBody>
-      </p:sp>
-      <p:sp>
-        <p:nvSpPr>
           <p:cNvPr id="13" name="TextBox 12"/>
           <p:cNvSpPr txBox="1"/>
           <p:nvPr/>
         </p:nvSpPr>
         <p:spPr>
           <a:xfrm>
-            <a:off x="8650224" y="2834639"/>
-            <a:ext cx="2953512" cy="1645920"/>
+            <a:off x="1874519" y="4526279"/>
+            <a:ext cx="9235440" cy="822960"/>
           </a:xfrm>
           <a:prstGeom prst="rect">
             <a:avLst/>
@@ -4154,17 +4156,17 @@
           <a:p>
             <a:pPr algn="l">
               <a:spcAft>
-                <a:spcPts val="600"/>
-              </a:spcAft>
-            </a:pPr>
-            <a:r>
-              <a:rPr sz="1800" b="1" i="0">
-                <a:solidFill>
-                  <a:srgbClr val="FFFFFF"/>
-                </a:solidFill>
-                <a:latin typeface="Calibri"/>
-              </a:rPr>
-              <a:t>Acquisition</a:t>
+                <a:spcPts val="200"/>
+              </a:spcAft>
+            </a:pPr>
+            <a:r>
+              <a:rPr sz="1600" b="1" i="0">
+                <a:solidFill>
+                  <a:srgbClr val="1B2B3A"/>
+                </a:solidFill>
+                <a:latin typeface="Calibri"/>
+              </a:rPr>
+              <a:t>Déploiement comme client</a:t>
             </a:r>
           </a:p>
           <a:p>
@@ -4174,13 +4176,13 @@
               </a:spcAft>
             </a:pPr>
             <a:r>
-              <a:rPr sz="1300" b="0" i="0">
-                <a:solidFill>
-                  <a:srgbClr val="C7D2DD"/>
-                </a:solidFill>
-                <a:latin typeface="Calibri"/>
-              </a:rPr>
-              <a:t>Rachat du produit + IP et intégration de l'équipe. CGI possède et industrialise l'actif.</a:t>
+              <a:rPr sz="1250" b="0" i="0">
+                <a:solidFill>
+                  <a:srgbClr val="647485"/>
+                </a:solidFill>
+                <a:latin typeface="Calibri"/>
+              </a:rPr>
+              <a:t>Extension à d'autres entités, en abonnement SaaS par licence, au rythme de CGI.</a:t>
             </a:r>
           </a:p>
         </p:txBody>
@@ -4188,45 +4190,6 @@
       <p:sp>
         <p:nvSpPr>
           <p:cNvPr id="14" name="TextBox 13"/>
-          <p:cNvSpPr txBox="1"/>
-          <p:nvPr/>
-        </p:nvSpPr>
-        <p:spPr>
-          <a:xfrm>
-            <a:off x="822960" y="4892040"/>
-            <a:ext cx="10515600" cy="548640"/>
-          </a:xfrm>
-          <a:prstGeom prst="rect">
-            <a:avLst/>
-          </a:prstGeom>
-          <a:noFill/>
-        </p:spPr>
-        <p:txBody>
-          <a:bodyPr wrap="square">
-            <a:spAutoFit/>
-          </a:bodyPr>
-          <a:lstStyle/>
-          <a:p>
-            <a:pPr algn="l">
-              <a:spcAft>
-                <a:spcPts val="500"/>
-              </a:spcAft>
-            </a:pPr>
-            <a:r>
-              <a:rPr sz="1400" b="0" i="1">
-                <a:solidFill>
-                  <a:srgbClr val="647485"/>
-                </a:solidFill>
-                <a:latin typeface="Calibri"/>
-              </a:rPr>
-              <a:t>Approche recommandée : commencer par un pilote pour prouver la valeur, avec une option d'acquisition/partenariat à la clé.</a:t>
-            </a:r>
-          </a:p>
-        </p:txBody>
-      </p:sp>
-      <p:sp>
-        <p:nvSpPr>
-          <p:cNvPr id="15" name="TextBox 14"/>
           <p:cNvSpPr txBox="1"/>
           <p:nvPr/>
         </p:nvSpPr>
@@ -4334,7 +4297,7 @@
         <p:spPr>
           <a:xfrm>
             <a:off x="822960" y="566928"/>
-            <a:ext cx="1700784" cy="384048"/>
+            <a:ext cx="1993392" cy="384048"/>
           </a:xfrm>
           <a:prstGeom prst="roundRect">
             <a:avLst/>
@@ -4377,7 +4340,7 @@
                 </a:solidFill>
                 <a:latin typeface="Calibri"/>
               </a:rPr>
-              <a:t>Vision</a:t>
+              <a:t>Et après</a:t>
             </a:r>
           </a:p>
         </p:txBody>
@@ -4416,30 +4379,71 @@
                 </a:solidFill>
                 <a:latin typeface="Calibri"/>
               </a:rPr>
-              <a:t>Ce que Konsilys devient, adossé à CGI</a:t>
-            </a:r>
-          </a:p>
-        </p:txBody>
-      </p:sp>
-      <p:sp>
-        <p:nvSpPr>
-          <p:cNvPr id="5" name="Oval 4"/>
+              <a:t>Commencer client, garder les options ouvertes</a:t>
+            </a:r>
+          </a:p>
+        </p:txBody>
+      </p:sp>
+      <p:sp>
+        <p:nvSpPr>
+          <p:cNvPr id="5" name="TextBox 4"/>
+          <p:cNvSpPr txBox="1"/>
+          <p:nvPr/>
+        </p:nvSpPr>
+        <p:spPr>
+          <a:xfrm>
+            <a:off x="822960" y="1828800"/>
+            <a:ext cx="10515600" cy="822960"/>
+          </a:xfrm>
+          <a:prstGeom prst="rect">
+            <a:avLst/>
+          </a:prstGeom>
+          <a:noFill/>
+        </p:spPr>
+        <p:txBody>
+          <a:bodyPr wrap="square">
+            <a:spAutoFit/>
+          </a:bodyPr>
+          <a:lstStyle/>
+          <a:p>
+            <a:pPr algn="l">
+              <a:spcAft>
+                <a:spcPts val="500"/>
+              </a:spcAft>
+            </a:pPr>
+            <a:r>
+              <a:rPr sz="1500" b="0" i="0">
+                <a:solidFill>
+                  <a:srgbClr val="647485"/>
+                </a:solidFill>
+                <a:latin typeface="Calibri"/>
+              </a:rPr>
+              <a:t>L'objectif immédiat est simple : que CGI adopte Konsilys comme solution. Si la collaboration se développe, plusieurs voies pourront s'ouvrir — à explorer plus tard, sans engagement aujourd'hui :</a:t>
+            </a:r>
+          </a:p>
+        </p:txBody>
+      </p:sp>
+      <p:sp>
+        <p:nvSpPr>
+          <p:cNvPr id="6" name="Rounded Rectangle 5"/>
           <p:cNvSpPr/>
           <p:nvPr/>
         </p:nvSpPr>
         <p:spPr>
           <a:xfrm>
-            <a:off x="868680" y="2103120"/>
-            <a:ext cx="502920" cy="502920"/>
-          </a:xfrm>
-          <a:prstGeom prst="ellipse">
-            <a:avLst/>
-          </a:prstGeom>
-          <a:solidFill>
-            <a:srgbClr val="84CC16"/>
-          </a:solidFill>
-          <a:ln>
-            <a:noFill/>
+            <a:off x="822960" y="2743200"/>
+            <a:ext cx="3502152" cy="2194560"/>
+          </a:xfrm>
+          <a:prstGeom prst="roundRect">
+            <a:avLst/>
+          </a:prstGeom>
+          <a:solidFill>
+            <a:srgbClr val="F7F9FB"/>
+          </a:solidFill>
+          <a:ln w="25400">
+            <a:solidFill>
+              <a:srgbClr val="84CC16"/>
+            </a:solidFill>
           </a:ln>
           <a:effectLst/>
         </p:spPr>
@@ -4461,33 +4465,132 @@
           <a:bodyPr rtlCol="0" anchor="ctr"/>
           <a:lstStyle/>
           <a:p>
+            <a:pPr algn="ctr"/>
+          </a:p>
+        </p:txBody>
+      </p:sp>
+      <p:sp>
+        <p:nvSpPr>
+          <p:cNvPr id="7" name="Rounded Rectangle 6"/>
+          <p:cNvSpPr/>
+          <p:nvPr/>
+        </p:nvSpPr>
+        <p:spPr>
+          <a:xfrm>
+            <a:off x="1097280" y="3017520"/>
+            <a:ext cx="2651760" cy="384048"/>
+          </a:xfrm>
+          <a:prstGeom prst="roundRect">
+            <a:avLst/>
+          </a:prstGeom>
+          <a:solidFill>
+            <a:srgbClr val="1B2B3A"/>
+          </a:solidFill>
+          <a:ln>
+            <a:noFill/>
+          </a:ln>
+          <a:effectLst/>
+        </p:spPr>
+        <p:style>
+          <a:lnRef idx="1">
+            <a:schemeClr val="accent1"/>
+          </a:lnRef>
+          <a:fillRef idx="3">
+            <a:schemeClr val="accent1"/>
+          </a:fillRef>
+          <a:effectRef idx="2">
+            <a:schemeClr val="accent1"/>
+          </a:effectRef>
+          <a:fontRef idx="minor">
+            <a:schemeClr val="lt1"/>
+          </a:fontRef>
+        </p:style>
+        <p:txBody>
+          <a:bodyPr rtlCol="0" anchor="ctr" wrap="square"/>
+          <a:lstStyle/>
+          <a:p>
             <a:pPr algn="ctr">
               <a:spcAft>
                 <a:spcPts val="500"/>
               </a:spcAft>
             </a:pPr>
             <a:r>
+              <a:rPr sz="1100" b="1" i="0">
+                <a:solidFill>
+                  <a:srgbClr val="FFFFFF"/>
+                </a:solidFill>
+                <a:latin typeface="Calibri"/>
+              </a:rPr>
+              <a:t>AUJOURD'HUI</a:t>
+            </a:r>
+          </a:p>
+        </p:txBody>
+      </p:sp>
+      <p:sp>
+        <p:nvSpPr>
+          <p:cNvPr id="8" name="TextBox 7"/>
+          <p:cNvSpPr txBox="1"/>
+          <p:nvPr/>
+        </p:nvSpPr>
+        <p:spPr>
+          <a:xfrm>
+            <a:off x="1097280" y="3566160"/>
+            <a:ext cx="2953512" cy="1280160"/>
+          </a:xfrm>
+          <a:prstGeom prst="rect">
+            <a:avLst/>
+          </a:prstGeom>
+          <a:noFill/>
+        </p:spPr>
+        <p:txBody>
+          <a:bodyPr wrap="square">
+            <a:spAutoFit/>
+          </a:bodyPr>
+          <a:lstStyle/>
+          <a:p>
+            <a:pPr algn="l">
+              <a:spcAft>
+                <a:spcPts val="600"/>
+              </a:spcAft>
+            </a:pPr>
+            <a:r>
               <a:rPr sz="1800" b="1" i="0">
                 <a:solidFill>
                   <a:srgbClr val="1B2B3A"/>
                 </a:solidFill>
                 <a:latin typeface="Calibri"/>
               </a:rPr>
-              <a:t>1</a:t>
-            </a:r>
-          </a:p>
-        </p:txBody>
-      </p:sp>
-      <p:sp>
-        <p:nvSpPr>
-          <p:cNvPr id="6" name="Rounded Rectangle 5"/>
+              <a:t>Client</a:t>
+            </a:r>
+          </a:p>
+          <a:p>
+            <a:pPr algn="l">
+              <a:spcAft>
+                <a:spcPts val="500"/>
+              </a:spcAft>
+            </a:pPr>
+            <a:r>
+              <a:rPr sz="1300" b="0" i="0">
+                <a:solidFill>
+                  <a:srgbClr val="647485"/>
+                </a:solidFill>
+                <a:latin typeface="Calibri"/>
+              </a:rPr>
+              <a:t>CGI utilise et déploie Konsilys sur ses entités, en abonnement.</a:t>
+            </a:r>
+          </a:p>
+        </p:txBody>
+      </p:sp>
+      <p:sp>
+        <p:nvSpPr>
+          <p:cNvPr id="9" name="Rounded Rectangle 8"/>
           <p:cNvSpPr/>
           <p:nvPr/>
         </p:nvSpPr>
         <p:spPr>
           <a:xfrm>
-            <a:off x="1600200" y="2011679"/>
-            <a:ext cx="9765792" cy="960120"/>
+            <a:off x="4599432" y="2743200"/>
+            <a:ext cx="3502152" cy="2194560"/>
           </a:xfrm>
           <a:prstGeom prst="roundRect">
             <a:avLst/>
@@ -4526,75 +4629,20 @@
       </p:sp>
       <p:sp>
         <p:nvSpPr>
-          <p:cNvPr id="7" name="TextBox 6"/>
-          <p:cNvSpPr txBox="1"/>
-          <p:nvPr/>
-        </p:nvSpPr>
-        <p:spPr>
-          <a:xfrm>
-            <a:off x="1874519" y="2148839"/>
-            <a:ext cx="9235440" cy="822960"/>
-          </a:xfrm>
-          <a:prstGeom prst="rect">
-            <a:avLst/>
-          </a:prstGeom>
-          <a:noFill/>
-        </p:spPr>
-        <p:txBody>
-          <a:bodyPr wrap="square">
-            <a:spAutoFit/>
-          </a:bodyPr>
-          <a:lstStyle/>
-          <a:p>
-            <a:pPr algn="l">
-              <a:spcAft>
-                <a:spcPts val="200"/>
-              </a:spcAft>
-            </a:pPr>
-            <a:r>
-              <a:rPr sz="1600" b="1" i="0">
-                <a:solidFill>
-                  <a:srgbClr val="1B2B3A"/>
-                </a:solidFill>
-                <a:latin typeface="Calibri"/>
-              </a:rPr>
-              <a:t>Intégration entreprise</a:t>
-            </a:r>
-          </a:p>
-          <a:p>
-            <a:pPr algn="l">
-              <a:spcAft>
-                <a:spcPts val="500"/>
-              </a:spcAft>
-            </a:pPr>
-            <a:r>
-              <a:rPr sz="1250" b="0" i="0">
-                <a:solidFill>
-                  <a:srgbClr val="647485"/>
-                </a:solidFill>
-                <a:latin typeface="Calibri"/>
-              </a:rPr>
-              <a:t>SSO / annuaire, connecteurs RH-paie et ERP, exports comptables.</a:t>
-            </a:r>
-          </a:p>
-        </p:txBody>
-      </p:sp>
-      <p:sp>
-        <p:nvSpPr>
-          <p:cNvPr id="8" name="Oval 7"/>
+          <p:cNvPr id="10" name="Rounded Rectangle 9"/>
           <p:cNvSpPr/>
           <p:nvPr/>
         </p:nvSpPr>
         <p:spPr>
           <a:xfrm>
-            <a:off x="868680" y="3291839"/>
-            <a:ext cx="502920" cy="502920"/>
-          </a:xfrm>
-          <a:prstGeom prst="ellipse">
-            <a:avLst/>
-          </a:prstGeom>
-          <a:solidFill>
-            <a:srgbClr val="84CC16"/>
+            <a:off x="4873752" y="3017520"/>
+            <a:ext cx="2651760" cy="384048"/>
+          </a:xfrm>
+          <a:prstGeom prst="roundRect">
+            <a:avLst/>
+          </a:prstGeom>
+          <a:solidFill>
+            <a:srgbClr val="E2E8F0"/>
           </a:solidFill>
           <a:ln>
             <a:noFill/>
@@ -4616,7 +4664,7 @@
           </a:fontRef>
         </p:style>
         <p:txBody>
-          <a:bodyPr rtlCol="0" anchor="ctr"/>
+          <a:bodyPr rtlCol="0" anchor="ctr" wrap="square"/>
           <a:lstStyle/>
           <a:p>
             <a:pPr algn="ctr">
@@ -4625,27 +4673,82 @@
               </a:spcAft>
             </a:pPr>
             <a:r>
+              <a:rPr sz="1100" b="1" i="0">
+                <a:solidFill>
+                  <a:srgbClr val="647485"/>
+                </a:solidFill>
+                <a:latin typeface="Calibri"/>
+              </a:rPr>
+              <a:t>PLUS TARD · OPTION</a:t>
+            </a:r>
+          </a:p>
+        </p:txBody>
+      </p:sp>
+      <p:sp>
+        <p:nvSpPr>
+          <p:cNvPr id="11" name="TextBox 10"/>
+          <p:cNvSpPr txBox="1"/>
+          <p:nvPr/>
+        </p:nvSpPr>
+        <p:spPr>
+          <a:xfrm>
+            <a:off x="4873752" y="3566160"/>
+            <a:ext cx="2953512" cy="1280160"/>
+          </a:xfrm>
+          <a:prstGeom prst="rect">
+            <a:avLst/>
+          </a:prstGeom>
+          <a:noFill/>
+        </p:spPr>
+        <p:txBody>
+          <a:bodyPr wrap="square">
+            <a:spAutoFit/>
+          </a:bodyPr>
+          <a:lstStyle/>
+          <a:p>
+            <a:pPr algn="l">
+              <a:spcAft>
+                <a:spcPts val="600"/>
+              </a:spcAft>
+            </a:pPr>
+            <a:r>
               <a:rPr sz="1800" b="1" i="0">
                 <a:solidFill>
                   <a:srgbClr val="1B2B3A"/>
                 </a:solidFill>
                 <a:latin typeface="Calibri"/>
               </a:rPr>
-              <a:t>2</a:t>
-            </a:r>
-          </a:p>
-        </p:txBody>
-      </p:sp>
-      <p:sp>
-        <p:nvSpPr>
-          <p:cNvPr id="9" name="Rounded Rectangle 8"/>
+              <a:t>Partenariat</a:t>
+            </a:r>
+          </a:p>
+          <a:p>
+            <a:pPr algn="l">
+              <a:spcAft>
+                <a:spcPts val="500"/>
+              </a:spcAft>
+            </a:pPr>
+            <a:r>
+              <a:rPr sz="1300" b="0" i="0">
+                <a:solidFill>
+                  <a:srgbClr val="647485"/>
+                </a:solidFill>
+                <a:latin typeface="Calibri"/>
+              </a:rPr>
+              <a:t>CGI distribue ou intègre Konsilys à son offre pour ses propres clients.</a:t>
+            </a:r>
+          </a:p>
+        </p:txBody>
+      </p:sp>
+      <p:sp>
+        <p:nvSpPr>
+          <p:cNvPr id="12" name="Rounded Rectangle 11"/>
           <p:cNvSpPr/>
           <p:nvPr/>
         </p:nvSpPr>
         <p:spPr>
           <a:xfrm>
-            <a:off x="1600200" y="3200399"/>
-            <a:ext cx="9765792" cy="960120"/>
+            <a:off x="8375904" y="2743200"/>
+            <a:ext cx="3502152" cy="2194560"/>
           </a:xfrm>
           <a:prstGeom prst="roundRect">
             <a:avLst/>
@@ -4684,75 +4787,20 @@
       </p:sp>
       <p:sp>
         <p:nvSpPr>
-          <p:cNvPr id="10" name="TextBox 9"/>
-          <p:cNvSpPr txBox="1"/>
-          <p:nvPr/>
-        </p:nvSpPr>
-        <p:spPr>
-          <a:xfrm>
-            <a:off x="1874519" y="3337559"/>
-            <a:ext cx="9235440" cy="822960"/>
-          </a:xfrm>
-          <a:prstGeom prst="rect">
-            <a:avLst/>
-          </a:prstGeom>
-          <a:noFill/>
-        </p:spPr>
-        <p:txBody>
-          <a:bodyPr wrap="square">
-            <a:spAutoFit/>
-          </a:bodyPr>
-          <a:lstStyle/>
-          <a:p>
-            <a:pPr algn="l">
-              <a:spcAft>
-                <a:spcPts val="200"/>
-              </a:spcAft>
-            </a:pPr>
-            <a:r>
-              <a:rPr sz="1600" b="1" i="0">
-                <a:solidFill>
-                  <a:srgbClr val="1B2B3A"/>
-                </a:solidFill>
-                <a:latin typeface="Calibri"/>
-              </a:rPr>
-              <a:t>Échelle groupe</a:t>
-            </a:r>
-          </a:p>
-          <a:p>
-            <a:pPr algn="l">
-              <a:spcAft>
-                <a:spcPts val="500"/>
-              </a:spcAft>
-            </a:pPr>
-            <a:r>
-              <a:rPr sz="1250" b="0" i="0">
-                <a:solidFill>
-                  <a:srgbClr val="647485"/>
-                </a:solidFill>
-                <a:latin typeface="Calibri"/>
-              </a:rPr>
-              <a:t>Multi-entités, consolidation, conformité et hébergement aux standards CGI.</a:t>
-            </a:r>
-          </a:p>
-        </p:txBody>
-      </p:sp>
-      <p:sp>
-        <p:nvSpPr>
-          <p:cNvPr id="11" name="Oval 10"/>
+          <p:cNvPr id="13" name="Rounded Rectangle 12"/>
           <p:cNvSpPr/>
           <p:nvPr/>
         </p:nvSpPr>
         <p:spPr>
           <a:xfrm>
-            <a:off x="868680" y="4480559"/>
-            <a:ext cx="502920" cy="502920"/>
-          </a:xfrm>
-          <a:prstGeom prst="ellipse">
-            <a:avLst/>
-          </a:prstGeom>
-          <a:solidFill>
-            <a:srgbClr val="84CC16"/>
+            <a:off x="8650224" y="3017520"/>
+            <a:ext cx="2651760" cy="384048"/>
+          </a:xfrm>
+          <a:prstGeom prst="roundRect">
+            <a:avLst/>
+          </a:prstGeom>
+          <a:solidFill>
+            <a:srgbClr val="E2E8F0"/>
           </a:solidFill>
           <a:ln>
             <a:noFill/>
@@ -4774,7 +4822,7 @@
           </a:fontRef>
         </p:style>
         <p:txBody>
-          <a:bodyPr rtlCol="0" anchor="ctr"/>
+          <a:bodyPr rtlCol="0" anchor="ctr" wrap="square"/>
           <a:lstStyle/>
           <a:p>
             <a:pPr algn="ctr">
@@ -4783,73 +4831,27 @@
               </a:spcAft>
             </a:pPr>
             <a:r>
-              <a:rPr sz="1800" b="1" i="0">
-                <a:solidFill>
-                  <a:srgbClr val="1B2B3A"/>
-                </a:solidFill>
-                <a:latin typeface="Calibri"/>
-              </a:rPr>
-              <a:t>3</a:t>
-            </a:r>
-          </a:p>
-        </p:txBody>
-      </p:sp>
-      <p:sp>
-        <p:nvSpPr>
-          <p:cNvPr id="12" name="Rounded Rectangle 11"/>
-          <p:cNvSpPr/>
-          <p:nvPr/>
-        </p:nvSpPr>
-        <p:spPr>
-          <a:xfrm>
-            <a:off x="1600200" y="4389120"/>
-            <a:ext cx="9765792" cy="960120"/>
-          </a:xfrm>
-          <a:prstGeom prst="roundRect">
-            <a:avLst/>
-          </a:prstGeom>
-          <a:solidFill>
-            <a:srgbClr val="F7F9FB"/>
-          </a:solidFill>
-          <a:ln w="12700">
-            <a:solidFill>
-              <a:srgbClr val="E2E8F0"/>
-            </a:solidFill>
-          </a:ln>
-          <a:effectLst/>
-        </p:spPr>
-        <p:style>
-          <a:lnRef idx="1">
-            <a:schemeClr val="accent1"/>
-          </a:lnRef>
-          <a:fillRef idx="3">
-            <a:schemeClr val="accent1"/>
-          </a:fillRef>
-          <a:effectRef idx="2">
-            <a:schemeClr val="accent1"/>
-          </a:effectRef>
-          <a:fontRef idx="minor">
-            <a:schemeClr val="lt1"/>
-          </a:fontRef>
-        </p:style>
-        <p:txBody>
-          <a:bodyPr rtlCol="0" anchor="ctr"/>
-          <a:lstStyle/>
-          <a:p>
-            <a:pPr algn="ctr"/>
-          </a:p>
-        </p:txBody>
-      </p:sp>
-      <p:sp>
-        <p:nvSpPr>
-          <p:cNvPr id="13" name="TextBox 12"/>
+              <a:rPr sz="1100" b="1" i="0">
+                <a:solidFill>
+                  <a:srgbClr val="647485"/>
+                </a:solidFill>
+                <a:latin typeface="Calibri"/>
+              </a:rPr>
+              <a:t>PLUS TARD · OPTION</a:t>
+            </a:r>
+          </a:p>
+        </p:txBody>
+      </p:sp>
+      <p:sp>
+        <p:nvSpPr>
+          <p:cNvPr id="14" name="TextBox 13"/>
           <p:cNvSpPr txBox="1"/>
           <p:nvPr/>
         </p:nvSpPr>
         <p:spPr>
           <a:xfrm>
-            <a:off x="1874519" y="4526279"/>
-            <a:ext cx="9235440" cy="822960"/>
+            <a:off x="8650224" y="3566160"/>
+            <a:ext cx="2953512" cy="1280160"/>
           </a:xfrm>
           <a:prstGeom prst="rect">
             <a:avLst/>
@@ -4864,17 +4866,17 @@
           <a:p>
             <a:pPr algn="l">
               <a:spcAft>
-                <a:spcPts val="200"/>
-              </a:spcAft>
-            </a:pPr>
-            <a:r>
-              <a:rPr sz="1600" b="1" i="0">
+                <a:spcPts val="600"/>
+              </a:spcAft>
+            </a:pPr>
+            <a:r>
+              <a:rPr sz="1800" b="1" i="0">
                 <a:solidFill>
                   <a:srgbClr val="1B2B3A"/>
                 </a:solidFill>
                 <a:latin typeface="Calibri"/>
               </a:rPr>
-              <a:t>Différenciation</a:t>
+              <a:t>Acquisition</a:t>
             </a:r>
           </a:p>
           <a:p>
@@ -4884,20 +4886,20 @@
               </a:spcAft>
             </a:pPr>
             <a:r>
-              <a:rPr sz="1250" b="0" i="0">
+              <a:rPr sz="1300" b="0" i="0">
                 <a:solidFill>
                   <a:srgbClr val="647485"/>
                 </a:solidFill>
                 <a:latin typeface="Calibri"/>
               </a:rPr>
-              <a:t>IA de staffing et recommandations : anticiper inter-contrats et optimiser la marge.</a:t>
-            </a:r>
-          </a:p>
-        </p:txBody>
-      </p:sp>
-      <p:sp>
-        <p:nvSpPr>
-          <p:cNvPr id="14" name="TextBox 13"/>
+              <a:t>Si le produit devient stratégique, une reprise du produit et de l'équipe reste envisageable.</a:t>
+            </a:r>
+          </a:p>
+        </p:txBody>
+      </p:sp>
+      <p:sp>
+        <p:nvSpPr>
+          <p:cNvPr id="15" name="TextBox 14"/>
           <p:cNvSpPr txBox="1"/>
           <p:nvPr/>
         </p:nvSpPr>
@@ -5048,7 +5050,7 @@
                 </a:solidFill>
                 <a:latin typeface="Calibri"/>
               </a:rPr>
-              <a:t>Équipe</a:t>
+              <a:t>Vision</a:t>
             </a:r>
           </a:p>
         </p:txBody>
@@ -5087,46 +5089,64 @@
                 </a:solidFill>
                 <a:latin typeface="Calibri"/>
               </a:rPr>
-              <a:t>Qui est derrière Konsilys</a:t>
-            </a:r>
-          </a:p>
-        </p:txBody>
-      </p:sp>
-      <p:sp>
-        <p:nvSpPr>
-          <p:cNvPr id="5" name="TextBox 4"/>
-          <p:cNvSpPr txBox="1"/>
-          <p:nvPr/>
-        </p:nvSpPr>
-        <p:spPr>
-          <a:xfrm>
-            <a:off x="822960" y="1828800"/>
-            <a:ext cx="10515600" cy="457200"/>
-          </a:xfrm>
-          <a:prstGeom prst="rect">
-            <a:avLst/>
-          </a:prstGeom>
-          <a:noFill/>
-        </p:spPr>
-        <p:txBody>
-          <a:bodyPr wrap="square">
-            <a:spAutoFit/>
-          </a:bodyPr>
-          <a:lstStyle/>
-          <a:p>
-            <a:pPr algn="l">
+              <a:t>Ce que Konsilys apporte à CGI dans la durée</a:t>
+            </a:r>
+          </a:p>
+        </p:txBody>
+      </p:sp>
+      <p:sp>
+        <p:nvSpPr>
+          <p:cNvPr id="5" name="Oval 4"/>
+          <p:cNvSpPr/>
+          <p:nvPr/>
+        </p:nvSpPr>
+        <p:spPr>
+          <a:xfrm>
+            <a:off x="868680" y="2103120"/>
+            <a:ext cx="502920" cy="502920"/>
+          </a:xfrm>
+          <a:prstGeom prst="ellipse">
+            <a:avLst/>
+          </a:prstGeom>
+          <a:solidFill>
+            <a:srgbClr val="84CC16"/>
+          </a:solidFill>
+          <a:ln>
+            <a:noFill/>
+          </a:ln>
+          <a:effectLst/>
+        </p:spPr>
+        <p:style>
+          <a:lnRef idx="1">
+            <a:schemeClr val="accent1"/>
+          </a:lnRef>
+          <a:fillRef idx="3">
+            <a:schemeClr val="accent1"/>
+          </a:fillRef>
+          <a:effectRef idx="2">
+            <a:schemeClr val="accent1"/>
+          </a:effectRef>
+          <a:fontRef idx="minor">
+            <a:schemeClr val="lt1"/>
+          </a:fontRef>
+        </p:style>
+        <p:txBody>
+          <a:bodyPr rtlCol="0" anchor="ctr"/>
+          <a:lstStyle/>
+          <a:p>
+            <a:pPr algn="ctr">
               <a:spcAft>
                 <a:spcPts val="500"/>
               </a:spcAft>
             </a:pPr>
             <a:r>
-              <a:rPr sz="1500" b="0" i="0">
-                <a:solidFill>
-                  <a:srgbClr val="647485"/>
-                </a:solidFill>
-                <a:latin typeface="Calibri"/>
-              </a:rPr>
-              <a:t>Le facteur clé d'une acquisition produit : l'équipe qui le porte.</a:t>
+              <a:rPr sz="1800" b="1" i="0">
+                <a:solidFill>
+                  <a:srgbClr val="1B2B3A"/>
+                </a:solidFill>
+                <a:latin typeface="Calibri"/>
+              </a:rPr>
+              <a:t>1</a:t>
             </a:r>
           </a:p>
         </p:txBody>
@@ -5139,8 +5159,8 @@
         </p:nvSpPr>
         <p:spPr>
           <a:xfrm>
-            <a:off x="822960" y="2377440"/>
-            <a:ext cx="3429000" cy="2651760"/>
+            <a:off x="1600200" y="2011679"/>
+            <a:ext cx="9765792" cy="960120"/>
           </a:xfrm>
           <a:prstGeom prst="roundRect">
             <a:avLst/>
@@ -5179,20 +5199,75 @@
       </p:sp>
       <p:sp>
         <p:nvSpPr>
-          <p:cNvPr id="7" name="Oval 6"/>
+          <p:cNvPr id="7" name="TextBox 6"/>
+          <p:cNvSpPr txBox="1"/>
+          <p:nvPr/>
+        </p:nvSpPr>
+        <p:spPr>
+          <a:xfrm>
+            <a:off x="1874519" y="2148839"/>
+            <a:ext cx="9235440" cy="822960"/>
+          </a:xfrm>
+          <a:prstGeom prst="rect">
+            <a:avLst/>
+          </a:prstGeom>
+          <a:noFill/>
+        </p:spPr>
+        <p:txBody>
+          <a:bodyPr wrap="square">
+            <a:spAutoFit/>
+          </a:bodyPr>
+          <a:lstStyle/>
+          <a:p>
+            <a:pPr algn="l">
+              <a:spcAft>
+                <a:spcPts val="200"/>
+              </a:spcAft>
+            </a:pPr>
+            <a:r>
+              <a:rPr sz="1600" b="1" i="0">
+                <a:solidFill>
+                  <a:srgbClr val="1B2B3A"/>
+                </a:solidFill>
+                <a:latin typeface="Calibri"/>
+              </a:rPr>
+              <a:t>Intégration entreprise</a:t>
+            </a:r>
+          </a:p>
+          <a:p>
+            <a:pPr algn="l">
+              <a:spcAft>
+                <a:spcPts val="500"/>
+              </a:spcAft>
+            </a:pPr>
+            <a:r>
+              <a:rPr sz="1250" b="0" i="0">
+                <a:solidFill>
+                  <a:srgbClr val="647485"/>
+                </a:solidFill>
+                <a:latin typeface="Calibri"/>
+              </a:rPr>
+              <a:t>SSO / annuaire, connecteurs RH-paie et ERP, exports comptables.</a:t>
+            </a:r>
+          </a:p>
+        </p:txBody>
+      </p:sp>
+      <p:sp>
+        <p:nvSpPr>
+          <p:cNvPr id="8" name="Oval 7"/>
           <p:cNvSpPr/>
           <p:nvPr/>
         </p:nvSpPr>
         <p:spPr>
           <a:xfrm>
-            <a:off x="2103120" y="2606040"/>
-            <a:ext cx="868680" cy="868680"/>
+            <a:off x="868680" y="3291839"/>
+            <a:ext cx="502920" cy="502920"/>
           </a:xfrm>
           <a:prstGeom prst="ellipse">
             <a:avLst/>
           </a:prstGeom>
           <a:solidFill>
-            <a:srgbClr val="1B2B3A"/>
+            <a:srgbClr val="84CC16"/>
           </a:solidFill>
           <a:ln>
             <a:noFill/>
@@ -5223,84 +5298,13 @@
               </a:spcAft>
             </a:pPr>
             <a:r>
-              <a:rPr sz="2400" b="1" i="0">
-                <a:solidFill>
-                  <a:srgbClr val="84CC16"/>
-                </a:solidFill>
-                <a:latin typeface="Calibri"/>
-              </a:rPr>
-              <a:t>?</a:t>
-            </a:r>
-          </a:p>
-        </p:txBody>
-      </p:sp>
-      <p:sp>
-        <p:nvSpPr>
-          <p:cNvPr id="8" name="TextBox 7"/>
-          <p:cNvSpPr txBox="1"/>
-          <p:nvPr/>
-        </p:nvSpPr>
-        <p:spPr>
-          <a:xfrm>
-            <a:off x="1097280" y="3657600"/>
-            <a:ext cx="2880360" cy="1280160"/>
-          </a:xfrm>
-          <a:prstGeom prst="rect">
-            <a:avLst/>
-          </a:prstGeom>
-          <a:noFill/>
-        </p:spPr>
-        <p:txBody>
-          <a:bodyPr wrap="square">
-            <a:spAutoFit/>
-          </a:bodyPr>
-          <a:lstStyle/>
-          <a:p>
-            <a:pPr algn="ctr">
-              <a:spcAft>
-                <a:spcPts val="300"/>
-              </a:spcAft>
-            </a:pPr>
-            <a:r>
-              <a:rPr sz="1600" b="1" i="0">
+              <a:rPr sz="1800" b="1" i="0">
                 <a:solidFill>
                   <a:srgbClr val="1B2B3A"/>
                 </a:solidFill>
                 <a:latin typeface="Calibri"/>
               </a:rPr>
-              <a:t>Prénom Nom</a:t>
-            </a:r>
-          </a:p>
-          <a:p>
-            <a:pPr algn="ctr">
-              <a:spcAft>
-                <a:spcPts val="500"/>
-              </a:spcAft>
-            </a:pPr>
-            <a:r>
-              <a:rPr sz="1300" b="0" i="0">
-                <a:solidFill>
-                  <a:srgbClr val="84CC16"/>
-                </a:solidFill>
-                <a:latin typeface="Calibri"/>
-              </a:rPr>
-              <a:t>Rôle</a:t>
-            </a:r>
-          </a:p>
-          <a:p>
-            <a:pPr algn="ctr">
-              <a:spcAft>
-                <a:spcPts val="500"/>
-              </a:spcAft>
-            </a:pPr>
-            <a:r>
-              <a:rPr sz="1150" b="0" i="0">
-                <a:solidFill>
-                  <a:srgbClr val="647485"/>
-                </a:solidFill>
-                <a:latin typeface="Calibri"/>
-              </a:rPr>
-              <a:t>Parcours, réalisations</a:t>
+              <a:t>2</a:t>
             </a:r>
           </a:p>
         </p:txBody>
@@ -5313,8 +5317,8 @@
         </p:nvSpPr>
         <p:spPr>
           <a:xfrm>
-            <a:off x="4526280" y="2377440"/>
-            <a:ext cx="3429000" cy="2651760"/>
+            <a:off x="1600200" y="3200399"/>
+            <a:ext cx="9765792" cy="960120"/>
           </a:xfrm>
           <a:prstGeom prst="roundRect">
             <a:avLst/>
@@ -5353,20 +5357,75 @@
       </p:sp>
       <p:sp>
         <p:nvSpPr>
-          <p:cNvPr id="10" name="Oval 9"/>
+          <p:cNvPr id="10" name="TextBox 9"/>
+          <p:cNvSpPr txBox="1"/>
+          <p:nvPr/>
+        </p:nvSpPr>
+        <p:spPr>
+          <a:xfrm>
+            <a:off x="1874519" y="3337559"/>
+            <a:ext cx="9235440" cy="822960"/>
+          </a:xfrm>
+          <a:prstGeom prst="rect">
+            <a:avLst/>
+          </a:prstGeom>
+          <a:noFill/>
+        </p:spPr>
+        <p:txBody>
+          <a:bodyPr wrap="square">
+            <a:spAutoFit/>
+          </a:bodyPr>
+          <a:lstStyle/>
+          <a:p>
+            <a:pPr algn="l">
+              <a:spcAft>
+                <a:spcPts val="200"/>
+              </a:spcAft>
+            </a:pPr>
+            <a:r>
+              <a:rPr sz="1600" b="1" i="0">
+                <a:solidFill>
+                  <a:srgbClr val="1B2B3A"/>
+                </a:solidFill>
+                <a:latin typeface="Calibri"/>
+              </a:rPr>
+              <a:t>Échelle groupe</a:t>
+            </a:r>
+          </a:p>
+          <a:p>
+            <a:pPr algn="l">
+              <a:spcAft>
+                <a:spcPts val="500"/>
+              </a:spcAft>
+            </a:pPr>
+            <a:r>
+              <a:rPr sz="1250" b="0" i="0">
+                <a:solidFill>
+                  <a:srgbClr val="647485"/>
+                </a:solidFill>
+                <a:latin typeface="Calibri"/>
+              </a:rPr>
+              <a:t>Multi-entités, consolidation, conformité et hébergement aux standards CGI.</a:t>
+            </a:r>
+          </a:p>
+        </p:txBody>
+      </p:sp>
+      <p:sp>
+        <p:nvSpPr>
+          <p:cNvPr id="11" name="Oval 10"/>
           <p:cNvSpPr/>
           <p:nvPr/>
         </p:nvSpPr>
         <p:spPr>
           <a:xfrm>
-            <a:off x="5806440" y="2606040"/>
-            <a:ext cx="868680" cy="868680"/>
+            <a:off x="868680" y="4480559"/>
+            <a:ext cx="502920" cy="502920"/>
           </a:xfrm>
           <a:prstGeom prst="ellipse">
             <a:avLst/>
           </a:prstGeom>
           <a:solidFill>
-            <a:srgbClr val="1B2B3A"/>
+            <a:srgbClr val="84CC16"/>
           </a:solidFill>
           <a:ln>
             <a:noFill/>
@@ -5397,84 +5456,13 @@
               </a:spcAft>
             </a:pPr>
             <a:r>
-              <a:rPr sz="2400" b="1" i="0">
-                <a:solidFill>
-                  <a:srgbClr val="84CC16"/>
-                </a:solidFill>
-                <a:latin typeface="Calibri"/>
-              </a:rPr>
-              <a:t>?</a:t>
-            </a:r>
-          </a:p>
-        </p:txBody>
-      </p:sp>
-      <p:sp>
-        <p:nvSpPr>
-          <p:cNvPr id="11" name="TextBox 10"/>
-          <p:cNvSpPr txBox="1"/>
-          <p:nvPr/>
-        </p:nvSpPr>
-        <p:spPr>
-          <a:xfrm>
-            <a:off x="4800600" y="3657600"/>
-            <a:ext cx="2880360" cy="1280160"/>
-          </a:xfrm>
-          <a:prstGeom prst="rect">
-            <a:avLst/>
-          </a:prstGeom>
-          <a:noFill/>
-        </p:spPr>
-        <p:txBody>
-          <a:bodyPr wrap="square">
-            <a:spAutoFit/>
-          </a:bodyPr>
-          <a:lstStyle/>
-          <a:p>
-            <a:pPr algn="ctr">
-              <a:spcAft>
-                <a:spcPts val="300"/>
-              </a:spcAft>
-            </a:pPr>
-            <a:r>
-              <a:rPr sz="1600" b="1" i="0">
+              <a:rPr sz="1800" b="1" i="0">
                 <a:solidFill>
                   <a:srgbClr val="1B2B3A"/>
                 </a:solidFill>
                 <a:latin typeface="Calibri"/>
               </a:rPr>
-              <a:t>Prénom Nom</a:t>
-            </a:r>
-          </a:p>
-          <a:p>
-            <a:pPr algn="ctr">
-              <a:spcAft>
-                <a:spcPts val="500"/>
-              </a:spcAft>
-            </a:pPr>
-            <a:r>
-              <a:rPr sz="1300" b="0" i="0">
-                <a:solidFill>
-                  <a:srgbClr val="84CC16"/>
-                </a:solidFill>
-                <a:latin typeface="Calibri"/>
-              </a:rPr>
-              <a:t>Rôle</a:t>
-            </a:r>
-          </a:p>
-          <a:p>
-            <a:pPr algn="ctr">
-              <a:spcAft>
-                <a:spcPts val="500"/>
-              </a:spcAft>
-            </a:pPr>
-            <a:r>
-              <a:rPr sz="1150" b="0" i="0">
-                <a:solidFill>
-                  <a:srgbClr val="647485"/>
-                </a:solidFill>
-                <a:latin typeface="Calibri"/>
-              </a:rPr>
-              <a:t>Parcours, réalisations</a:t>
+              <a:t>3</a:t>
             </a:r>
           </a:p>
         </p:txBody>
@@ -5487,8 +5475,8 @@
         </p:nvSpPr>
         <p:spPr>
           <a:xfrm>
-            <a:off x="8229600" y="2377440"/>
-            <a:ext cx="3429000" cy="2651760"/>
+            <a:off x="1600200" y="4389120"/>
+            <a:ext cx="9765792" cy="960120"/>
           </a:xfrm>
           <a:prstGeom prst="roundRect">
             <a:avLst/>
@@ -5527,71 +5515,14 @@
       </p:sp>
       <p:sp>
         <p:nvSpPr>
-          <p:cNvPr id="13" name="Oval 12"/>
-          <p:cNvSpPr/>
-          <p:nvPr/>
-        </p:nvSpPr>
-        <p:spPr>
-          <a:xfrm>
-            <a:off x="9509760" y="2606040"/>
-            <a:ext cx="868680" cy="868680"/>
-          </a:xfrm>
-          <a:prstGeom prst="ellipse">
-            <a:avLst/>
-          </a:prstGeom>
-          <a:solidFill>
-            <a:srgbClr val="1B2B3A"/>
-          </a:solidFill>
-          <a:ln>
-            <a:noFill/>
-          </a:ln>
-          <a:effectLst/>
-        </p:spPr>
-        <p:style>
-          <a:lnRef idx="1">
-            <a:schemeClr val="accent1"/>
-          </a:lnRef>
-          <a:fillRef idx="3">
-            <a:schemeClr val="accent1"/>
-          </a:fillRef>
-          <a:effectRef idx="2">
-            <a:schemeClr val="accent1"/>
-          </a:effectRef>
-          <a:fontRef idx="minor">
-            <a:schemeClr val="lt1"/>
-          </a:fontRef>
-        </p:style>
-        <p:txBody>
-          <a:bodyPr rtlCol="0" anchor="ctr"/>
-          <a:lstStyle/>
-          <a:p>
-            <a:pPr algn="ctr">
-              <a:spcAft>
-                <a:spcPts val="500"/>
-              </a:spcAft>
-            </a:pPr>
-            <a:r>
-              <a:rPr sz="2400" b="1" i="0">
-                <a:solidFill>
-                  <a:srgbClr val="84CC16"/>
-                </a:solidFill>
-                <a:latin typeface="Calibri"/>
-              </a:rPr>
-              <a:t>?</a:t>
-            </a:r>
-          </a:p>
-        </p:txBody>
-      </p:sp>
-      <p:sp>
-        <p:nvSpPr>
-          <p:cNvPr id="14" name="TextBox 13"/>
+          <p:cNvPr id="13" name="TextBox 12"/>
           <p:cNvSpPr txBox="1"/>
           <p:nvPr/>
         </p:nvSpPr>
         <p:spPr>
           <a:xfrm>
-            <a:off x="8503920" y="3657600"/>
-            <a:ext cx="2880360" cy="1280160"/>
+            <a:off x="1874519" y="4526279"/>
+            <a:ext cx="9235440" cy="822960"/>
           </a:xfrm>
           <a:prstGeom prst="rect">
             <a:avLst/>
@@ -5604,9 +5535,9 @@
           </a:bodyPr>
           <a:lstStyle/>
           <a:p>
-            <a:pPr algn="ctr">
-              <a:spcAft>
-                <a:spcPts val="300"/>
+            <a:pPr algn="l">
+              <a:spcAft>
+                <a:spcPts val="200"/>
               </a:spcAft>
             </a:pPr>
             <a:r>
@@ -5616,105 +5547,30 @@
                 </a:solidFill>
                 <a:latin typeface="Calibri"/>
               </a:rPr>
-              <a:t>Prénom Nom</a:t>
-            </a:r>
-          </a:p>
-          <a:p>
-            <a:pPr algn="ctr">
+              <a:t>Différenciation</a:t>
+            </a:r>
+          </a:p>
+          <a:p>
+            <a:pPr algn="l">
               <a:spcAft>
                 <a:spcPts val="500"/>
               </a:spcAft>
             </a:pPr>
             <a:r>
-              <a:rPr sz="1300" b="0" i="0">
-                <a:solidFill>
-                  <a:srgbClr val="84CC16"/>
-                </a:solidFill>
-                <a:latin typeface="Calibri"/>
-              </a:rPr>
-              <a:t>Rôle</a:t>
-            </a:r>
-          </a:p>
-          <a:p>
-            <a:pPr algn="ctr">
-              <a:spcAft>
-                <a:spcPts val="500"/>
-              </a:spcAft>
-            </a:pPr>
-            <a:r>
-              <a:rPr sz="1150" b="0" i="0">
+              <a:rPr sz="1250" b="0" i="0">
                 <a:solidFill>
                   <a:srgbClr val="647485"/>
                 </a:solidFill>
                 <a:latin typeface="Calibri"/>
               </a:rPr>
-              <a:t>Parcours, réalisations</a:t>
-            </a:r>
-          </a:p>
-        </p:txBody>
-      </p:sp>
-      <p:sp>
-        <p:nvSpPr>
-          <p:cNvPr id="15" name="Rounded Rectangle 14"/>
-          <p:cNvSpPr/>
-          <p:nvPr/>
-        </p:nvSpPr>
-        <p:spPr>
-          <a:xfrm>
-            <a:off x="822960" y="5989320"/>
-            <a:ext cx="10543032" cy="502920"/>
-          </a:xfrm>
-          <a:prstGeom prst="roundRect">
-            <a:avLst/>
-          </a:prstGeom>
-          <a:solidFill>
-            <a:srgbClr val="FFF7E0"/>
-          </a:solidFill>
-          <a:ln w="12700">
-            <a:solidFill>
-              <a:srgbClr val="E9C46A"/>
-            </a:solidFill>
-          </a:ln>
-          <a:effectLst/>
-        </p:spPr>
-        <p:style>
-          <a:lnRef idx="1">
-            <a:schemeClr val="accent1"/>
-          </a:lnRef>
-          <a:fillRef idx="3">
-            <a:schemeClr val="accent1"/>
-          </a:fillRef>
-          <a:effectRef idx="2">
-            <a:schemeClr val="accent1"/>
-          </a:effectRef>
-          <a:fontRef idx="minor">
-            <a:schemeClr val="lt1"/>
-          </a:fontRef>
-        </p:style>
-        <p:txBody>
-          <a:bodyPr rtlCol="0" anchor="ctr" wrap="square"/>
-          <a:lstStyle/>
-          <a:p>
-            <a:pPr algn="l">
-              <a:spcAft>
-                <a:spcPts val="500"/>
-              </a:spcAft>
-            </a:pPr>
-            <a:r>
-              <a:rPr sz="1050" b="1" i="0">
-                <a:solidFill>
-                  <a:srgbClr val="8A6D1E"/>
-                </a:solidFill>
-                <a:latin typeface="Calibri"/>
-              </a:rPr>
-              <a:t>À COMPLÉTER — renseigner ton parcours (et l'équipe), ton rôle chez CGI, et ta position sur une intégration</a:t>
-            </a:r>
-          </a:p>
-        </p:txBody>
-      </p:sp>
-      <p:sp>
-        <p:nvSpPr>
-          <p:cNvPr id="16" name="TextBox 15"/>
+              <a:t>IA de staffing et recommandations : anticiper inter-contrats et optimiser la marge.</a:t>
+            </a:r>
+          </a:p>
+        </p:txBody>
+      </p:sp>
+      <p:sp>
+        <p:nvSpPr>
+          <p:cNvPr id="14" name="TextBox 13"/>
           <p:cNvSpPr txBox="1"/>
           <p:nvPr/>
         </p:nvSpPr>
@@ -5904,7 +5760,7 @@
                 </a:solidFill>
                 <a:latin typeface="Calibri"/>
               </a:rPr>
-              <a:t>Des prochaines étapes concrètes</a:t>
+              <a:t>Un premier pas concret : le pilote</a:t>
             </a:r>
           </a:p>
         </p:txBody>
@@ -5918,7 +5774,7 @@
         <p:spPr>
           <a:xfrm>
             <a:off x="822960" y="2103120"/>
-            <a:ext cx="3331464" cy="1920240"/>
+            <a:ext cx="3331464" cy="1828800"/>
           </a:xfrm>
           <a:prstGeom prst="roundRect">
             <a:avLst/>
@@ -6008,7 +5864,7 @@
         <p:spPr>
           <a:xfrm>
             <a:off x="1097280" y="2560320"/>
-            <a:ext cx="2782823" cy="1280160"/>
+            <a:ext cx="2782823" cy="1188720"/>
           </a:xfrm>
           <a:prstGeom prst="rect">
             <a:avLst/>
@@ -6033,7 +5889,7 @@
                 </a:solidFill>
                 <a:latin typeface="Calibri"/>
               </a:rPr>
-              <a:t>1. Un pilote</a:t>
+              <a:t>1. Une entité</a:t>
             </a:r>
           </a:p>
           <a:p>
@@ -6049,7 +5905,7 @@
                 </a:solidFill>
                 <a:latin typeface="Calibri"/>
               </a:rPr>
-              <a:t>Choisir ensemble une entité/BU pour un déploiement test cadré (objectifs, durée, indicateurs).</a:t>
+              <a:t>Choisir ensemble une filiale ou BU volontaire pour un pilote cadré.</a:t>
             </a:r>
           </a:p>
         </p:txBody>
@@ -6063,7 +5919,7 @@
         <p:spPr>
           <a:xfrm>
             <a:off x="4428744" y="2103120"/>
-            <a:ext cx="3331464" cy="1920240"/>
+            <a:ext cx="3331464" cy="1828800"/>
           </a:xfrm>
           <a:prstGeom prst="roundRect">
             <a:avLst/>
@@ -6153,7 +6009,7 @@
         <p:spPr>
           <a:xfrm>
             <a:off x="4703063" y="2560320"/>
-            <a:ext cx="2782823" cy="1280160"/>
+            <a:ext cx="2782823" cy="1188720"/>
           </a:xfrm>
           <a:prstGeom prst="rect">
             <a:avLst/>
@@ -6178,7 +6034,7 @@
                 </a:solidFill>
                 <a:latin typeface="Calibri"/>
               </a:rPr>
-              <a:t>2. Due diligence</a:t>
+              <a:t>2. Un pilote mesuré</a:t>
             </a:r>
           </a:p>
           <a:p>
@@ -6194,7 +6050,7 @@
                 </a:solidFill>
                 <a:latin typeface="Calibri"/>
               </a:rPr>
-              <a:t>Ouvrir l'accès technique, sécurité et juridique (dont la propriété intellectuelle) pour évaluer l'actif.</a:t>
+              <a:t>Objectifs, durée et indicateurs clairs. Mise en route en quelques jours.</a:t>
             </a:r>
           </a:p>
         </p:txBody>
@@ -6208,7 +6064,7 @@
         <p:spPr>
           <a:xfrm>
             <a:off x="8034527" y="2103120"/>
-            <a:ext cx="3331464" cy="1920240"/>
+            <a:ext cx="3331464" cy="1828800"/>
           </a:xfrm>
           <a:prstGeom prst="roundRect">
             <a:avLst/>
@@ -6298,7 +6154,7 @@
         <p:spPr>
           <a:xfrm>
             <a:off x="8308847" y="2560320"/>
-            <a:ext cx="2782823" cy="1280160"/>
+            <a:ext cx="2782823" cy="1188720"/>
           </a:xfrm>
           <a:prstGeom prst="rect">
             <a:avLst/>
@@ -6323,7 +6179,7 @@
                 </a:solidFill>
                 <a:latin typeface="Calibri"/>
               </a:rPr>
-              <a:t>3. Cadre de deal</a:t>
+              <a:t>3. Le déploiement</a:t>
             </a:r>
           </a:p>
           <a:p>
@@ -6339,7 +6195,7 @@
                 </a:solidFill>
                 <a:latin typeface="Calibri"/>
               </a:rPr>
-              <a:t>Discuter les termes d'un partenariat ou d'une acquisition selon les résultats du pilote.</a:t>
+              <a:t>Si concluant, extension à d'autres entités en abonnement.</a:t>
             </a:r>
           </a:p>
         </p:txBody>
@@ -6352,7 +6208,7 @@
         </p:nvSpPr>
         <p:spPr>
           <a:xfrm>
-            <a:off x="822960" y="4480560"/>
+            <a:off x="822960" y="4389120"/>
             <a:ext cx="10543032" cy="868680"/>
           </a:xfrm>
           <a:prstGeom prst="roundRect">
@@ -6396,7 +6252,7 @@
         </p:nvSpPr>
         <p:spPr>
           <a:xfrm>
-            <a:off x="1097280" y="4645152"/>
+            <a:off x="1097280" y="4553712"/>
             <a:ext cx="10058400" cy="548640"/>
           </a:xfrm>
           <a:prstGeom prst="rect">
@@ -6422,7 +6278,7 @@
                 </a:solidFill>
                 <a:latin typeface="Calibri"/>
               </a:rPr>
-              <a:t>Notre demande : lancer un pilote sur une entité, et entrer en discussion.</a:t>
+              <a:t>Notre demande : lancer un pilote sur une entité volontaire.</a:t>
             </a:r>
           </a:p>
         </p:txBody>
@@ -6821,7 +6677,7 @@
                 </a:solidFill>
                 <a:latin typeface="Calibri"/>
               </a:rPr>
-              <a:t>Un actif prêt. Le partenaire idéal, c'est CGI.</a:t>
+              <a:t>Une solution prête. Démarrons par un pilote.</a:t>
             </a:r>
           </a:p>
           <a:p>
@@ -6837,7 +6693,7 @@
                 </a:solidFill>
                 <a:latin typeface="Calibri"/>
               </a:rPr>
-              <a:t>Un produit en production, un marché que CGI connaît mieux que quiconque, et des synergies immédiates — en interne comme en offre.</a:t>
+              <a:t>Un produit en production, un déploiement en quelques jours, et une valeur mesurable dès la première entité — au rythme de CGI.</a:t>
             </a:r>
           </a:p>
         </p:txBody>
@@ -7034,7 +6890,7 @@
                 </a:solidFill>
                 <a:latin typeface="Calibri"/>
               </a:rPr>
-              <a:t>Un produit prêt, deux opportunités pour CGI</a:t>
+              <a:t>Un outil d'agilité, prêt à déployer pour CGI</a:t>
             </a:r>
           </a:p>
         </p:txBody>
@@ -7073,7 +6929,7 @@
                 </a:solidFill>
                 <a:latin typeface="Calibri"/>
               </a:rPr>
-              <a:t>Konsilys est une plateforme opérationnelle et commerciale pour ESN, construite et déployée en production. Elle a une place naturelle dans l'écosystème CGI, sur deux fronts :</a:t>
+              <a:t>Konsilys est une plateforme opérationnelle pour sociétés de conseil, en production. CGI peut l'adopter dès aujourd'hui pour piloter les entités que le SI groupe sert mal — sans projet lourd.</a:t>
             </a:r>
           </a:p>
         </p:txBody>
@@ -7202,7 +7058,7 @@
                 </a:solidFill>
                 <a:latin typeface="Calibri"/>
               </a:rPr>
-              <a:t>Un levier d'agilité interne</a:t>
+              <a:t>Déployable tout de suite</a:t>
             </a:r>
           </a:p>
           <a:p>
@@ -7218,7 +7074,7 @@
                 </a:solidFill>
                 <a:latin typeface="Calibri"/>
               </a:rPr>
-              <a:t>Outiller en quelques minutes les entités mal servies par l'ERP groupe : filiales, acquisitions, BU, joint-ventures.</a:t>
+              <a:t>Opérationnel en quelques minutes sur une entité : import Excel/CSV, aucun chantier d'intégration préalable.</a:t>
             </a:r>
           </a:p>
         </p:txBody>
@@ -7347,7 +7203,7 @@
                 </a:solidFill>
                 <a:latin typeface="Calibri"/>
               </a:rPr>
-              <a:t>Un actif produit</a:t>
+              <a:t>Complémentaire à votre SI</a:t>
             </a:r>
           </a:p>
           <a:p>
@@ -7363,7 +7219,7 @@
                 </a:solidFill>
                 <a:latin typeface="Calibri"/>
               </a:rPr>
-              <a:t>Un SaaS moderne que CGI pourrait porter, distribuer à ses clients ou intégrer à son offre — au lieu de le construire.</a:t>
+              <a:t>Konsilys ne remplace pas l'ERP : il comble l'opérationnel léger (staffing, marge, absences, CRM) là où l'ERP est lourd.</a:t>
             </a:r>
           </a:p>
         </p:txBody>
@@ -8124,7 +7980,7 @@
                 </a:solidFill>
                 <a:latin typeface="Calibri"/>
               </a:rPr>
-              <a:t>Un marché immense, connu de CGI</a:t>
+              <a:t>Un besoin quotidien pour les managers</a:t>
             </a:r>
           </a:p>
           <a:p>
@@ -8140,7 +7996,7 @@
                 </a:solidFill>
                 <a:latin typeface="Calibri"/>
               </a:rPr>
-              <a:t>Des centaines de milliers de consultants en France, des millions en Europe : le métier même de CGI.</a:t>
+              <a:t>Staffing à l'aveugle, marge recalculée à la main, validations par mail : du temps perdu au quotidien.</a:t>
             </a:r>
           </a:p>
         </p:txBody>
@@ -9366,7 +9222,7 @@
         <p:spPr>
           <a:xfrm>
             <a:off x="822960" y="566928"/>
-            <a:ext cx="1847088" cy="384048"/>
+            <a:ext cx="2432304" cy="384048"/>
           </a:xfrm>
           <a:prstGeom prst="roundRect">
             <a:avLst/>
@@ -9409,7 +9265,7 @@
                 </a:solidFill>
                 <a:latin typeface="Calibri"/>
               </a:rPr>
-              <a:t>L'actif</a:t>
+              <a:t>La solution</a:t>
             </a:r>
           </a:p>
         </p:txBody>
@@ -9448,7 +9304,7 @@
                 </a:solidFill>
                 <a:latin typeface="Calibri"/>
               </a:rPr>
-              <a:t>Ce que CGI acquiert : un produit fonctionnel, pas une promesse</a:t>
+              <a:t>En production, prête pour un groupe comme CGI</a:t>
             </a:r>
           </a:p>
         </p:txBody>
@@ -9575,7 +9431,7 @@
                 </a:solidFill>
                 <a:latin typeface="Calibri"/>
               </a:rPr>
-              <a:t>Réel, pas un concept</a:t>
+              <a:t>En production</a:t>
             </a:r>
           </a:p>
           <a:p>
@@ -9591,7 +9447,7 @@
                 </a:solidFill>
                 <a:latin typeface="Calibri"/>
               </a:rPr>
-              <a:t>Produit en production : souscription, paiement, provisioning et pilotage fonctionnent de bout en bout.</a:t>
+              <a:t>Produit déployé : souscription, pilotage et provisioning fonctionnent de bout en bout. Rien à construire.</a:t>
             </a:r>
           </a:p>
         </p:txBody>
@@ -9718,7 +9574,7 @@
                 </a:solidFill>
                 <a:latin typeface="Calibri"/>
               </a:rPr>
-              <a:t>Architecture moderne</a:t>
+              <a:t>Moderne &amp; sécurisée</a:t>
             </a:r>
           </a:p>
           <a:p>
@@ -9734,7 +9590,7 @@
                 </a:solidFill>
                 <a:latin typeface="Calibri"/>
               </a:rPr>
-              <a:t>SaaS multi-tenant, PostgreSQL, isolation par entreprise (RLS), paiement Stripe. Hébergement en Europe.</a:t>
+              <a:t>SaaS multi-tenant, isolation stricte par entité (RLS), paiement délégué (Stripe), hébergement Europe (RGPD).</a:t>
             </a:r>
           </a:p>
         </p:txBody>
@@ -9861,7 +9717,7 @@
                 </a:solidFill>
                 <a:latin typeface="Calibri"/>
               </a:rPr>
-              <a:t>Sécurité by design</a:t>
+              <a:t>Prête à s'intégrer</a:t>
             </a:r>
           </a:p>
           <a:p>
@@ -9877,7 +9733,7 @@
                 </a:solidFill>
                 <a:latin typeface="Calibri"/>
               </a:rPr>
-              <a:t>Cloisonnement strict, moindre privilège, RGPD. Prêt à recevoir SSO / annuaire d'entreprise.</a:t>
+              <a:t>Architecture ouverte (API, fonctions serveur). Prête à recevoir SSO/annuaire et à s'aligner sur les standards CGI.</a:t>
             </a:r>
           </a:p>
         </p:txBody>
@@ -10661,7 +10517,7 @@
                 </a:solidFill>
                 <a:latin typeface="Calibri"/>
               </a:rPr>
-              <a:t>Modèle extensible</a:t>
+              <a:t>Modèle par licence</a:t>
             </a:r>
           </a:p>
         </p:txBody>
@@ -10746,7 +10602,7 @@
                 </a:solidFill>
                 <a:latin typeface="Calibri"/>
               </a:rPr>
-              <a:t>Licence par rôle et par siège : revenu qui croît avec l'usage, adoption progressive.</a:t>
+              <a:t>Tarif par rôle et par siège : vous ne payez que l'usage réel, entité par entité.</a:t>
             </a:r>
           </a:p>
         </p:txBody>
@@ -10905,7 +10761,7 @@
         <p:spPr>
           <a:xfrm>
             <a:off x="822960" y="566928"/>
-            <a:ext cx="2578608" cy="384048"/>
+            <a:ext cx="1993392" cy="384048"/>
           </a:xfrm>
           <a:prstGeom prst="roundRect">
             <a:avLst/>
@@ -10948,7 +10804,7 @@
                 </a:solidFill>
                 <a:latin typeface="Calibri"/>
               </a:rPr>
-              <a:t>Pourquoi CGI</a:t>
+              <a:t>Pour CGI</a:t>
             </a:r>
           </a:p>
         </p:txBody>
@@ -10987,7 +10843,7 @@
                 </a:solidFill>
                 <a:latin typeface="Calibri"/>
               </a:rPr>
-              <a:t>Deux façons de créer de la valeur, tout de suite</a:t>
+              <a:t>Où Konsilys crée de la valeur chez vous</a:t>
             </a:r>
           </a:p>
         </p:txBody>
@@ -11045,7 +10901,7 @@
         <p:spPr>
           <a:xfrm>
             <a:off x="1143000" y="2286000"/>
-            <a:ext cx="2743200" cy="384048"/>
+            <a:ext cx="2286000" cy="384048"/>
           </a:xfrm>
           <a:prstGeom prst="roundRect">
             <a:avLst/>
@@ -11088,7 +10944,7 @@
                 </a:solidFill>
                 <a:latin typeface="Calibri"/>
               </a:rPr>
-              <a:t>VECTEUR 1 · INTERNE</a:t>
+              <a:t>CAS D'USAGE 1</a:t>
             </a:r>
           </a:p>
         </p:txBody>
@@ -11127,7 +10983,7 @@
                 </a:solidFill>
                 <a:latin typeface="Calibri"/>
               </a:rPr>
-              <a:t>Agilité pour le groupe</a:t>
+              <a:t>Filiales &amp; petites BU</a:t>
             </a:r>
           </a:p>
           <a:p>
@@ -11143,7 +10999,7 @@
                 </a:solidFill>
                 <a:latin typeface="Calibri"/>
               </a:rPr>
-              <a:t>Déployer Konsilys sur les entités mal outillées et les acquisitions récentes : visibilité opérationnelle immédiate, sans attendre l'intégration à l'ERP. Accélère et dérisque le post-merger.</a:t>
+              <a:t>Outiller en quelques minutes les entités mal servies par l'ERP groupe : pilotage, marge et staffing en temps réel, sans attendre un projet SI.</a:t>
             </a:r>
           </a:p>
         </p:txBody>
@@ -11201,7 +11057,7 @@
         <p:spPr>
           <a:xfrm>
             <a:off x="6775704" y="2286000"/>
-            <a:ext cx="2743200" cy="384048"/>
+            <a:ext cx="2286000" cy="384048"/>
           </a:xfrm>
           <a:prstGeom prst="roundRect">
             <a:avLst/>
@@ -11244,7 +11100,7 @@
                 </a:solidFill>
                 <a:latin typeface="Calibri"/>
               </a:rPr>
-              <a:t>VECTEUR 2 · OFFRE</a:t>
+              <a:t>CAS D'USAGE 2</a:t>
             </a:r>
           </a:p>
         </p:txBody>
@@ -11283,7 +11139,7 @@
                 </a:solidFill>
                 <a:latin typeface="Calibri"/>
               </a:rPr>
-              <a:t>Un produit à porter</a:t>
+              <a:t>Post-acquisition</a:t>
             </a:r>
           </a:p>
           <a:p>
@@ -11299,7 +11155,7 @@
                 </a:solidFill>
                 <a:latin typeface="Calibri"/>
               </a:rPr>
-              <a:t>CGI peut distribuer Konsilys à ses propres clients (ESN, DSI, cabinets) ou l'intégrer à ses services managés — un revenu SaaS récurrent et une vitrine d'innovation.</a:t>
+              <a:t>Donner une visibilité opérationnelle immédiate sur une entité récemment rachetée, le temps de son intégration. Accélère et dérisque le post-merger.</a:t>
             </a:r>
           </a:p>
         </p:txBody>
@@ -11338,7 +11194,7 @@
                 </a:solidFill>
                 <a:latin typeface="Calibri"/>
               </a:rPr>
-              <a:t>Konsilys ne remplace pas l'ERP de CGI : il occupe l'espace agile que l'ERP ne couvre pas, en interne comme en offre client.</a:t>
+              <a:t>Konsilys ne remplace pas l'ERP de CGI : il occupe l'espace agile que l'ERP ne couvre pas.</a:t>
             </a:r>
           </a:p>
         </p:txBody>
@@ -11496,7 +11352,7 @@
                 </a:solidFill>
                 <a:latin typeface="Calibri"/>
               </a:rPr>
-              <a:t>Synergies</a:t>
+              <a:t>La valeur</a:t>
             </a:r>
           </a:p>
         </p:txBody>
@@ -11535,7 +11391,7 @@
                 </a:solidFill>
                 <a:latin typeface="Calibri"/>
               </a:rPr>
-              <a:t>1 + 1 = 3</a:t>
+              <a:t>Ce que CGI y gagne, concrètement</a:t>
             </a:r>
           </a:p>
         </p:txBody>
@@ -11549,7 +11405,7 @@
         <p:spPr>
           <a:xfrm>
             <a:off x="822960" y="1965960"/>
-            <a:ext cx="5358384" cy="2286000"/>
+            <a:ext cx="5134355" cy="1783080"/>
           </a:xfrm>
           <a:prstGeom prst="roundRect">
             <a:avLst/>
@@ -11588,123 +11444,20 @@
       </p:sp>
       <p:sp>
         <p:nvSpPr>
-          <p:cNvPr id="6" name="TextBox 5"/>
-          <p:cNvSpPr txBox="1"/>
-          <p:nvPr/>
-        </p:nvSpPr>
-        <p:spPr>
-          <a:xfrm>
-            <a:off x="1097280" y="2194560"/>
-            <a:ext cx="4846320" cy="1920240"/>
-          </a:xfrm>
-          <a:prstGeom prst="rect">
-            <a:avLst/>
-          </a:prstGeom>
-          <a:noFill/>
-        </p:spPr>
-        <p:txBody>
-          <a:bodyPr wrap="square">
-            <a:spAutoFit/>
-          </a:bodyPr>
-          <a:lstStyle/>
-          <a:p>
-            <a:pPr algn="l">
-              <a:spcAft>
-                <a:spcPts val="800"/>
-              </a:spcAft>
-            </a:pPr>
-            <a:r>
-              <a:rPr sz="1800" b="1" i="0">
-                <a:solidFill>
-                  <a:srgbClr val="1B2B3A"/>
-                </a:solidFill>
-                <a:latin typeface="Calibri"/>
-              </a:rPr>
-              <a:t>Ce que CGI apporte</a:t>
-            </a:r>
-          </a:p>
-          <a:p>
-            <a:pPr algn="l">
-              <a:spcAft>
-                <a:spcPts val="400"/>
-              </a:spcAft>
-            </a:pPr>
-            <a:r>
-              <a:rPr sz="1300" b="0" i="0">
-                <a:solidFill>
-                  <a:srgbClr val="647485"/>
-                </a:solidFill>
-                <a:latin typeface="Calibri"/>
-              </a:rPr>
-              <a:t>•  Base clients massive et force commerciale</a:t>
-            </a:r>
-          </a:p>
-          <a:p>
-            <a:pPr algn="l">
-              <a:spcAft>
-                <a:spcPts val="400"/>
-              </a:spcAft>
-            </a:pPr>
-            <a:r>
-              <a:rPr sz="1300" b="0" i="0">
-                <a:solidFill>
-                  <a:srgbClr val="647485"/>
-                </a:solidFill>
-                <a:latin typeface="Calibri"/>
-              </a:rPr>
-              <a:t>•  Marque, crédibilité, confiance des DSI</a:t>
-            </a:r>
-          </a:p>
-          <a:p>
-            <a:pPr algn="l">
-              <a:spcAft>
-                <a:spcPts val="400"/>
-              </a:spcAft>
-            </a:pPr>
-            <a:r>
-              <a:rPr sz="1300" b="0" i="0">
-                <a:solidFill>
-                  <a:srgbClr val="647485"/>
-                </a:solidFill>
-                <a:latin typeface="Calibri"/>
-              </a:rPr>
-              <a:t>•  Capital et industrialisation</a:t>
-            </a:r>
-          </a:p>
-          <a:p>
-            <a:pPr algn="l">
-              <a:spcAft>
-                <a:spcPts val="400"/>
-              </a:spcAft>
-            </a:pPr>
-            <a:r>
-              <a:rPr sz="1300" b="0" i="0">
-                <a:solidFill>
-                  <a:srgbClr val="647485"/>
-                </a:solidFill>
-                <a:latin typeface="Calibri"/>
-              </a:rPr>
-              <a:t>•  Expertise d'intégration (SSO, ERP, sécurité)</a:t>
-            </a:r>
-          </a:p>
-        </p:txBody>
-      </p:sp>
-      <p:sp>
-        <p:nvSpPr>
-          <p:cNvPr id="7" name="Rounded Rectangle 6"/>
+          <p:cNvPr id="6" name="Rectangle 5"/>
           <p:cNvSpPr/>
           <p:nvPr/>
         </p:nvSpPr>
         <p:spPr>
           <a:xfrm>
-            <a:off x="6455664" y="1965960"/>
-            <a:ext cx="4910328" cy="2286000"/>
-          </a:xfrm>
-          <a:prstGeom prst="roundRect">
-            <a:avLst/>
-          </a:prstGeom>
-          <a:solidFill>
-            <a:srgbClr val="0F1720"/>
+            <a:off x="1097280" y="2221991"/>
+            <a:ext cx="457200" cy="100584"/>
+          </a:xfrm>
+          <a:prstGeom prst="rect">
+            <a:avLst/>
+          </a:prstGeom>
+          <a:solidFill>
+            <a:srgbClr val="84CC16"/>
           </a:solidFill>
           <a:ln>
             <a:noFill/>
@@ -11735,14 +11488,14 @@
       </p:sp>
       <p:sp>
         <p:nvSpPr>
-          <p:cNvPr id="8" name="TextBox 7"/>
+          <p:cNvPr id="7" name="TextBox 6"/>
           <p:cNvSpPr txBox="1"/>
           <p:nvPr/>
         </p:nvSpPr>
         <p:spPr>
           <a:xfrm>
-            <a:off x="6729984" y="2194560"/>
-            <a:ext cx="4389120" cy="1920240"/>
+            <a:off x="1097280" y="2423160"/>
+            <a:ext cx="4585716" cy="1143000"/>
           </a:xfrm>
           <a:prstGeom prst="rect">
             <a:avLst/>
@@ -11757,104 +11510,58 @@
           <a:p>
             <a:pPr algn="l">
               <a:spcAft>
-                <a:spcPts val="800"/>
-              </a:spcAft>
-            </a:pPr>
-            <a:r>
-              <a:rPr sz="1800" b="1" i="0">
-                <a:solidFill>
-                  <a:srgbClr val="84CC16"/>
-                </a:solidFill>
-                <a:latin typeface="Calibri"/>
-              </a:rPr>
-              <a:t>Ce que Konsilys apporte</a:t>
+                <a:spcPts val="500"/>
+              </a:spcAft>
+            </a:pPr>
+            <a:r>
+              <a:rPr sz="1600" b="1" i="0">
+                <a:solidFill>
+                  <a:srgbClr val="1B2B3A"/>
+                </a:solidFill>
+                <a:latin typeface="Calibri"/>
+              </a:rPr>
+              <a:t>Visibilité immédiate</a:t>
             </a:r>
           </a:p>
           <a:p>
             <a:pPr algn="l">
               <a:spcAft>
-                <a:spcPts val="400"/>
-              </a:spcAft>
-            </a:pPr>
-            <a:r>
-              <a:rPr sz="1300" b="0" i="0">
-                <a:solidFill>
-                  <a:srgbClr val="C7D2DD"/>
-                </a:solidFill>
-                <a:latin typeface="Calibri"/>
-              </a:rPr>
-              <a:t>•  Un produit SaaS moderne, déjà livré</a:t>
-            </a:r>
-          </a:p>
-          <a:p>
-            <a:pPr algn="l">
-              <a:spcAft>
-                <a:spcPts val="400"/>
-              </a:spcAft>
-            </a:pPr>
-            <a:r>
-              <a:rPr sz="1300" b="0" i="0">
-                <a:solidFill>
-                  <a:srgbClr val="C7D2DD"/>
-                </a:solidFill>
-                <a:latin typeface="Calibri"/>
-              </a:rPr>
-              <a:t>•  Rapidité et culture produit</a:t>
-            </a:r>
-          </a:p>
-          <a:p>
-            <a:pPr algn="l">
-              <a:spcAft>
-                <a:spcPts val="400"/>
-              </a:spcAft>
-            </a:pPr>
-            <a:r>
-              <a:rPr sz="1300" b="0" i="0">
-                <a:solidFill>
-                  <a:srgbClr val="C7D2DD"/>
-                </a:solidFill>
-                <a:latin typeface="Calibri"/>
-              </a:rPr>
-              <a:t>•  Un actif différenciant, clé en main</a:t>
-            </a:r>
-          </a:p>
-          <a:p>
-            <a:pPr algn="l">
-              <a:spcAft>
-                <a:spcPts val="400"/>
-              </a:spcAft>
-            </a:pPr>
-            <a:r>
-              <a:rPr sz="1300" b="0" i="0">
-                <a:solidFill>
-                  <a:srgbClr val="C7D2DD"/>
-                </a:solidFill>
-                <a:latin typeface="Calibri"/>
-              </a:rPr>
-              <a:t>•  L'équipe qui le fait évoluer</a:t>
-            </a:r>
-          </a:p>
-        </p:txBody>
-      </p:sp>
-      <p:sp>
-        <p:nvSpPr>
-          <p:cNvPr id="9" name="Rounded Rectangle 8"/>
+                <a:spcPts val="500"/>
+              </a:spcAft>
+            </a:pPr>
+            <a:r>
+              <a:rPr sz="1250" b="0" i="0">
+                <a:solidFill>
+                  <a:srgbClr val="647485"/>
+                </a:solidFill>
+                <a:latin typeface="Calibri"/>
+              </a:rPr>
+              <a:t>Staffing, CA et marge en temps réel dès le premier jour, sans chantier.</a:t>
+            </a:r>
+          </a:p>
+        </p:txBody>
+      </p:sp>
+      <p:sp>
+        <p:nvSpPr>
+          <p:cNvPr id="8" name="Rounded Rectangle 7"/>
           <p:cNvSpPr/>
           <p:nvPr/>
         </p:nvSpPr>
         <p:spPr>
           <a:xfrm>
-            <a:off x="822960" y="4480560"/>
-            <a:ext cx="10543032" cy="914400"/>
+            <a:off x="6231636" y="1965960"/>
+            <a:ext cx="5134355" cy="1783080"/>
           </a:xfrm>
           <a:prstGeom prst="roundRect">
             <a:avLst/>
           </a:prstGeom>
           <a:solidFill>
-            <a:srgbClr val="1B2B3A"/>
-          </a:solidFill>
-          <a:ln>
-            <a:noFill/>
+            <a:srgbClr val="F7F9FB"/>
+          </a:solidFill>
+          <a:ln w="12700">
+            <a:solidFill>
+              <a:srgbClr val="E2E8F0"/>
+            </a:solidFill>
           </a:ln>
           <a:effectLst/>
         </p:spPr>
@@ -11882,14 +11589,58 @@
       </p:sp>
       <p:sp>
         <p:nvSpPr>
+          <p:cNvPr id="9" name="Rectangle 8"/>
+          <p:cNvSpPr/>
+          <p:nvPr/>
+        </p:nvSpPr>
+        <p:spPr>
+          <a:xfrm>
+            <a:off x="6505955" y="2221991"/>
+            <a:ext cx="457200" cy="100584"/>
+          </a:xfrm>
+          <a:prstGeom prst="rect">
+            <a:avLst/>
+          </a:prstGeom>
+          <a:solidFill>
+            <a:srgbClr val="84CC16"/>
+          </a:solidFill>
+          <a:ln>
+            <a:noFill/>
+          </a:ln>
+          <a:effectLst/>
+        </p:spPr>
+        <p:style>
+          <a:lnRef idx="1">
+            <a:schemeClr val="accent1"/>
+          </a:lnRef>
+          <a:fillRef idx="3">
+            <a:schemeClr val="accent1"/>
+          </a:fillRef>
+          <a:effectRef idx="2">
+            <a:schemeClr val="accent1"/>
+          </a:effectRef>
+          <a:fontRef idx="minor">
+            <a:schemeClr val="lt1"/>
+          </a:fontRef>
+        </p:style>
+        <p:txBody>
+          <a:bodyPr rtlCol="0" anchor="ctr"/>
+          <a:lstStyle/>
+          <a:p>
+            <a:pPr algn="ctr"/>
+          </a:p>
+        </p:txBody>
+      </p:sp>
+      <p:sp>
+        <p:nvSpPr>
           <p:cNvPr id="10" name="TextBox 9"/>
           <p:cNvSpPr txBox="1"/>
           <p:nvPr/>
         </p:nvSpPr>
         <p:spPr>
           <a:xfrm>
-            <a:off x="1097280" y="4681728"/>
-            <a:ext cx="10058400" cy="548640"/>
+            <a:off x="6505955" y="2423160"/>
+            <a:ext cx="4585716" cy="1143000"/>
           </a:xfrm>
           <a:prstGeom prst="rect">
             <a:avLst/>
@@ -11902,26 +11653,332 @@
           </a:bodyPr>
           <a:lstStyle/>
           <a:p>
-            <a:pPr algn="ctr">
+            <a:pPr algn="l">
               <a:spcAft>
                 <a:spcPts val="500"/>
               </a:spcAft>
             </a:pPr>
             <a:r>
-              <a:rPr sz="1700" b="1" i="0">
-                <a:solidFill>
-                  <a:srgbClr val="FFFFFF"/>
-                </a:solidFill>
-                <a:latin typeface="Calibri"/>
-              </a:rPr>
-              <a:t>Distribution CGI × Produit Konsilys = une accélération que ni l'un ni l'autre n'atteint seul.</a:t>
-            </a:r>
-          </a:p>
-        </p:txBody>
-      </p:sp>
-      <p:sp>
-        <p:nvSpPr>
-          <p:cNvPr id="11" name="TextBox 10"/>
+              <a:rPr sz="1600" b="1" i="0">
+                <a:solidFill>
+                  <a:srgbClr val="1B2B3A"/>
+                </a:solidFill>
+                <a:latin typeface="Calibri"/>
+              </a:rPr>
+              <a:t>Productivité managériale</a:t>
+            </a:r>
+          </a:p>
+          <a:p>
+            <a:pPr algn="l">
+              <a:spcAft>
+                <a:spcPts val="500"/>
+              </a:spcAft>
+            </a:pPr>
+            <a:r>
+              <a:rPr sz="1250" b="0" i="0">
+                <a:solidFill>
+                  <a:srgbClr val="647485"/>
+                </a:solidFill>
+                <a:latin typeface="Calibri"/>
+              </a:rPr>
+              <a:t>Fini les ressaisies et les validations par mail : les managers pilotent, ne compilent plus.</a:t>
+            </a:r>
+          </a:p>
+        </p:txBody>
+      </p:sp>
+      <p:sp>
+        <p:nvSpPr>
+          <p:cNvPr id="11" name="Rounded Rectangle 10"/>
+          <p:cNvSpPr/>
+          <p:nvPr/>
+        </p:nvSpPr>
+        <p:spPr>
+          <a:xfrm>
+            <a:off x="822960" y="4023360"/>
+            <a:ext cx="5134355" cy="1783080"/>
+          </a:xfrm>
+          <a:prstGeom prst="roundRect">
+            <a:avLst/>
+          </a:prstGeom>
+          <a:solidFill>
+            <a:srgbClr val="F7F9FB"/>
+          </a:solidFill>
+          <a:ln w="12700">
+            <a:solidFill>
+              <a:srgbClr val="E2E8F0"/>
+            </a:solidFill>
+          </a:ln>
+          <a:effectLst/>
+        </p:spPr>
+        <p:style>
+          <a:lnRef idx="1">
+            <a:schemeClr val="accent1"/>
+          </a:lnRef>
+          <a:fillRef idx="3">
+            <a:schemeClr val="accent1"/>
+          </a:fillRef>
+          <a:effectRef idx="2">
+            <a:schemeClr val="accent1"/>
+          </a:effectRef>
+          <a:fontRef idx="minor">
+            <a:schemeClr val="lt1"/>
+          </a:fontRef>
+        </p:style>
+        <p:txBody>
+          <a:bodyPr rtlCol="0" anchor="ctr"/>
+          <a:lstStyle/>
+          <a:p>
+            <a:pPr algn="ctr"/>
+          </a:p>
+        </p:txBody>
+      </p:sp>
+      <p:sp>
+        <p:nvSpPr>
+          <p:cNvPr id="12" name="Rectangle 11"/>
+          <p:cNvSpPr/>
+          <p:nvPr/>
+        </p:nvSpPr>
+        <p:spPr>
+          <a:xfrm>
+            <a:off x="1097280" y="4279392"/>
+            <a:ext cx="457200" cy="100584"/>
+          </a:xfrm>
+          <a:prstGeom prst="rect">
+            <a:avLst/>
+          </a:prstGeom>
+          <a:solidFill>
+            <a:srgbClr val="84CC16"/>
+          </a:solidFill>
+          <a:ln>
+            <a:noFill/>
+          </a:ln>
+          <a:effectLst/>
+        </p:spPr>
+        <p:style>
+          <a:lnRef idx="1">
+            <a:schemeClr val="accent1"/>
+          </a:lnRef>
+          <a:fillRef idx="3">
+            <a:schemeClr val="accent1"/>
+          </a:fillRef>
+          <a:effectRef idx="2">
+            <a:schemeClr val="accent1"/>
+          </a:effectRef>
+          <a:fontRef idx="minor">
+            <a:schemeClr val="lt1"/>
+          </a:fontRef>
+        </p:style>
+        <p:txBody>
+          <a:bodyPr rtlCol="0" anchor="ctr"/>
+          <a:lstStyle/>
+          <a:p>
+            <a:pPr algn="ctr"/>
+          </a:p>
+        </p:txBody>
+      </p:sp>
+      <p:sp>
+        <p:nvSpPr>
+          <p:cNvPr id="13" name="TextBox 12"/>
+          <p:cNvSpPr txBox="1"/>
+          <p:nvPr/>
+        </p:nvSpPr>
+        <p:spPr>
+          <a:xfrm>
+            <a:off x="1097280" y="4480560"/>
+            <a:ext cx="4585716" cy="1143000"/>
+          </a:xfrm>
+          <a:prstGeom prst="rect">
+            <a:avLst/>
+          </a:prstGeom>
+          <a:noFill/>
+        </p:spPr>
+        <p:txBody>
+          <a:bodyPr wrap="square">
+            <a:spAutoFit/>
+          </a:bodyPr>
+          <a:lstStyle/>
+          <a:p>
+            <a:pPr algn="l">
+              <a:spcAft>
+                <a:spcPts val="500"/>
+              </a:spcAft>
+            </a:pPr>
+            <a:r>
+              <a:rPr sz="1600" b="1" i="0">
+                <a:solidFill>
+                  <a:srgbClr val="1B2B3A"/>
+                </a:solidFill>
+                <a:latin typeface="Calibri"/>
+              </a:rPr>
+              <a:t>Sans risque</a:t>
+            </a:r>
+          </a:p>
+          <a:p>
+            <a:pPr algn="l">
+              <a:spcAft>
+                <a:spcPts val="500"/>
+              </a:spcAft>
+            </a:pPr>
+            <a:r>
+              <a:rPr sz="1250" b="0" i="0">
+                <a:solidFill>
+                  <a:srgbClr val="647485"/>
+                </a:solidFill>
+                <a:latin typeface="Calibri"/>
+              </a:rPr>
+              <a:t>On démarre par un pilote cadré : pas de refonte du SI, réversibilité totale.</a:t>
+            </a:r>
+          </a:p>
+        </p:txBody>
+      </p:sp>
+      <p:sp>
+        <p:nvSpPr>
+          <p:cNvPr id="14" name="Rounded Rectangle 13"/>
+          <p:cNvSpPr/>
+          <p:nvPr/>
+        </p:nvSpPr>
+        <p:spPr>
+          <a:xfrm>
+            <a:off x="6231636" y="4023360"/>
+            <a:ext cx="5134355" cy="1783080"/>
+          </a:xfrm>
+          <a:prstGeom prst="roundRect">
+            <a:avLst/>
+          </a:prstGeom>
+          <a:solidFill>
+            <a:srgbClr val="F7F9FB"/>
+          </a:solidFill>
+          <a:ln w="12700">
+            <a:solidFill>
+              <a:srgbClr val="E2E8F0"/>
+            </a:solidFill>
+          </a:ln>
+          <a:effectLst/>
+        </p:spPr>
+        <p:style>
+          <a:lnRef idx="1">
+            <a:schemeClr val="accent1"/>
+          </a:lnRef>
+          <a:fillRef idx="3">
+            <a:schemeClr val="accent1"/>
+          </a:fillRef>
+          <a:effectRef idx="2">
+            <a:schemeClr val="accent1"/>
+          </a:effectRef>
+          <a:fontRef idx="minor">
+            <a:schemeClr val="lt1"/>
+          </a:fontRef>
+        </p:style>
+        <p:txBody>
+          <a:bodyPr rtlCol="0" anchor="ctr"/>
+          <a:lstStyle/>
+          <a:p>
+            <a:pPr algn="ctr"/>
+          </a:p>
+        </p:txBody>
+      </p:sp>
+      <p:sp>
+        <p:nvSpPr>
+          <p:cNvPr id="15" name="Rectangle 14"/>
+          <p:cNvSpPr/>
+          <p:nvPr/>
+        </p:nvSpPr>
+        <p:spPr>
+          <a:xfrm>
+            <a:off x="6505955" y="4279392"/>
+            <a:ext cx="457200" cy="100584"/>
+          </a:xfrm>
+          <a:prstGeom prst="rect">
+            <a:avLst/>
+          </a:prstGeom>
+          <a:solidFill>
+            <a:srgbClr val="84CC16"/>
+          </a:solidFill>
+          <a:ln>
+            <a:noFill/>
+          </a:ln>
+          <a:effectLst/>
+        </p:spPr>
+        <p:style>
+          <a:lnRef idx="1">
+            <a:schemeClr val="accent1"/>
+          </a:lnRef>
+          <a:fillRef idx="3">
+            <a:schemeClr val="accent1"/>
+          </a:fillRef>
+          <a:effectRef idx="2">
+            <a:schemeClr val="accent1"/>
+          </a:effectRef>
+          <a:fontRef idx="minor">
+            <a:schemeClr val="lt1"/>
+          </a:fontRef>
+        </p:style>
+        <p:txBody>
+          <a:bodyPr rtlCol="0" anchor="ctr"/>
+          <a:lstStyle/>
+          <a:p>
+            <a:pPr algn="ctr"/>
+          </a:p>
+        </p:txBody>
+      </p:sp>
+      <p:sp>
+        <p:nvSpPr>
+          <p:cNvPr id="16" name="TextBox 15"/>
+          <p:cNvSpPr txBox="1"/>
+          <p:nvPr/>
+        </p:nvSpPr>
+        <p:spPr>
+          <a:xfrm>
+            <a:off x="6505955" y="4480560"/>
+            <a:ext cx="4585716" cy="1143000"/>
+          </a:xfrm>
+          <a:prstGeom prst="rect">
+            <a:avLst/>
+          </a:prstGeom>
+          <a:noFill/>
+        </p:spPr>
+        <p:txBody>
+          <a:bodyPr wrap="square">
+            <a:spAutoFit/>
+          </a:bodyPr>
+          <a:lstStyle/>
+          <a:p>
+            <a:pPr algn="l">
+              <a:spcAft>
+                <a:spcPts val="500"/>
+              </a:spcAft>
+            </a:pPr>
+            <a:r>
+              <a:rPr sz="1600" b="1" i="0">
+                <a:solidFill>
+                  <a:srgbClr val="1B2B3A"/>
+                </a:solidFill>
+                <a:latin typeface="Calibri"/>
+              </a:rPr>
+              <a:t>Coût maîtrisé</a:t>
+            </a:r>
+          </a:p>
+          <a:p>
+            <a:pPr algn="l">
+              <a:spcAft>
+                <a:spcPts val="500"/>
+              </a:spcAft>
+            </a:pPr>
+            <a:r>
+              <a:rPr sz="1250" b="0" i="0">
+                <a:solidFill>
+                  <a:srgbClr val="647485"/>
+                </a:solidFill>
+                <a:latin typeface="Calibri"/>
+              </a:rPr>
+              <a:t>SaaS par licence : vous payez l'usage réel, entité par entité, sans intégration lourde.</a:t>
+            </a:r>
+          </a:p>
+        </p:txBody>
+      </p:sp>
+      <p:sp>
+        <p:nvSpPr>
+          <p:cNvPr id="17" name="TextBox 16"/>
           <p:cNvSpPr txBox="1"/>
           <p:nvPr/>
         </p:nvSpPr>
@@ -12452,7 +12509,7 @@
                 </a:solidFill>
                 <a:latin typeface="Calibri"/>
               </a:rPr>
-              <a:t>Souscription Stripe de bout en bout</a:t>
+              <a:t>Souscription de bout en bout</a:t>
             </a:r>
           </a:p>
         </p:txBody>
@@ -12610,7 +12667,7 @@
                 </a:solidFill>
                 <a:latin typeface="Calibri"/>
               </a:rPr>
-              <a:t>À COMPLÉTER — chiffrer : nb d'entreprises/consultants gérés, retours utilisateurs, MRR éventuel, démo live à préparer</a:t>
+              <a:t>À COMPLÉTER — chiffrer : nb d'entreprises/consultants gérés, retours utilisateurs, et préparer une démo live</a:t>
             </a:r>
           </a:p>
         </p:txBody>

</xml_diff>